<commit_message>
docs: add expanded research report, technical design document, and user stories
- Research report expanded to ~44 pages: styled dark/grid C4 diagrams, Gantt chart, attack/defend lab section, and a frontend gallery in both light and dark themes.

- New Technical Design Document (additional-docs/) covering user stories, architecture, data model, API, runtime flows and a traceability matrix.

- Styled user-story cards (HTML) with per-epic screenshots.

- Helper scripts for frontend/C4/user-story capture and diagram/report/TDD generation.
</commit_message>
<xml_diff>
--- a/docs/AnomalyDetector-Presentation.pptx
+++ b/docs/AnomalyDetector-Presentation.pptx
@@ -5,21 +5,21 @@
     <p:sldMasterId id="2147483648" r:id="rId1"/>
   </p:sldMasterIdLst>
   <p:sldIdLst>
-    <p:sldId id="256" r:id="rId7"/>
-    <p:sldId id="257" r:id="rId8"/>
-    <p:sldId id="258" r:id="rId9"/>
-    <p:sldId id="259" r:id="rId10"/>
-    <p:sldId id="260" r:id="rId11"/>
-    <p:sldId id="261" r:id="rId12"/>
-    <p:sldId id="262" r:id="rId13"/>
-    <p:sldId id="263" r:id="rId14"/>
-    <p:sldId id="264" r:id="rId15"/>
-    <p:sldId id="265" r:id="rId16"/>
-    <p:sldId id="266" r:id="rId17"/>
-    <p:sldId id="267" r:id="rId18"/>
-    <p:sldId id="268" r:id="rId19"/>
+    <p:sldId id="256" r:id="rId2"/>
+    <p:sldId id="257" r:id="rId3"/>
+    <p:sldId id="258" r:id="rId4"/>
+    <p:sldId id="259" r:id="rId5"/>
+    <p:sldId id="260" r:id="rId6"/>
+    <p:sldId id="261" r:id="rId7"/>
+    <p:sldId id="262" r:id="rId8"/>
+    <p:sldId id="263" r:id="rId9"/>
+    <p:sldId id="264" r:id="rId10"/>
+    <p:sldId id="265" r:id="rId11"/>
+    <p:sldId id="266" r:id="rId12"/>
+    <p:sldId id="267" r:id="rId13"/>
+    <p:sldId id="268" r:id="rId14"/>
   </p:sldIdLst>
-  <p:sldSz cx="12191695" cy="6858000" type="screen4x3"/>
+  <p:sldSz cx="12192000" cy="6858000"/>
   <p:notesSz cx="6858000" cy="9144000"/>
   <p:defaultTextStyle>
     <a:defPPr>
@@ -116,6 +116,22 @@
       </a:defRPr>
     </a:lvl9pPr>
   </p:defaultTextStyle>
+  <p:extLst>
+    <p:ext uri="{EFAFB233-063F-42B5-8137-9DF3F51BA10A}">
+      <p15:sldGuideLst xmlns:p15="http://schemas.microsoft.com/office/powerpoint/2012/main">
+        <p15:guide id="1" orient="horz" pos="2160">
+          <p15:clr>
+            <a:srgbClr val="A4A3A4"/>
+          </p15:clr>
+        </p15:guide>
+        <p15:guide id="2" pos="2880">
+          <p15:clr>
+            <a:srgbClr val="A4A3A4"/>
+          </p15:clr>
+        </p15:guide>
+      </p15:sldGuideLst>
+    </p:ext>
+  </p:extLst>
 </p:presentation>
 </file>
 
@@ -157,10 +173,9 @@
           <a:lstStyle/>
           <a:p>
             <a:r>
-              <a:rPr lang="en-US" smtClean="0"/>
+              <a:rPr lang="en-US"/>
               <a:t>Click to edit Master title style</a:t>
             </a:r>
-            <a:endParaRPr lang="en-US"/>
           </a:p>
         </p:txBody>
       </p:sp>
@@ -276,10 +291,9 @@
           </a:lstStyle>
           <a:p>
             <a:r>
-              <a:rPr lang="en-US" smtClean="0"/>
+              <a:rPr lang="en-US"/>
               <a:t>Click to edit Master subtitle style</a:t>
             </a:r>
-            <a:endParaRPr lang="en-US"/>
           </a:p>
         </p:txBody>
       </p:sp>
@@ -300,7 +314,7 @@
           <a:p>
             <a:fld id="{5BCAD085-E8A6-8845-BD4E-CB4CCA059FC4}" type="datetimeFigureOut">
               <a:rPr lang="en-US" smtClean="0"/>
-              <a:t>1/27/13</a:t>
+              <a:t>6/3/2026</a:t>
             </a:fld>
             <a:endParaRPr lang="en-US"/>
           </a:p>
@@ -394,10 +408,9 @@
           <a:lstStyle/>
           <a:p>
             <a:r>
-              <a:rPr lang="en-US" smtClean="0"/>
+              <a:rPr lang="en-US"/>
               <a:t>Click to edit Master title style</a:t>
             </a:r>
-            <a:endParaRPr lang="en-US"/>
           </a:p>
         </p:txBody>
       </p:sp>
@@ -418,38 +431,37 @@
           <a:p>
             <a:pPr lvl="0"/>
             <a:r>
-              <a:rPr lang="en-US" smtClean="0"/>
+              <a:rPr lang="en-US"/>
               <a:t>Click to edit Master text styles</a:t>
             </a:r>
           </a:p>
           <a:p>
             <a:pPr lvl="1"/>
             <a:r>
-              <a:rPr lang="en-US" smtClean="0"/>
+              <a:rPr lang="en-US"/>
               <a:t>Second level</a:t>
             </a:r>
           </a:p>
           <a:p>
             <a:pPr lvl="2"/>
             <a:r>
-              <a:rPr lang="en-US" smtClean="0"/>
+              <a:rPr lang="en-US"/>
               <a:t>Third level</a:t>
             </a:r>
           </a:p>
           <a:p>
             <a:pPr lvl="3"/>
             <a:r>
-              <a:rPr lang="en-US" smtClean="0"/>
+              <a:rPr lang="en-US"/>
               <a:t>Fourth level</a:t>
             </a:r>
           </a:p>
           <a:p>
             <a:pPr lvl="4"/>
             <a:r>
-              <a:rPr lang="en-US" smtClean="0"/>
+              <a:rPr lang="en-US"/>
               <a:t>Fifth level</a:t>
             </a:r>
-            <a:endParaRPr lang="en-US"/>
           </a:p>
         </p:txBody>
       </p:sp>
@@ -470,7 +482,7 @@
           <a:p>
             <a:fld id="{5BCAD085-E8A6-8845-BD4E-CB4CCA059FC4}" type="datetimeFigureOut">
               <a:rPr lang="en-US" smtClean="0"/>
-              <a:t>1/27/13</a:t>
+              <a:t>6/3/2026</a:t>
             </a:fld>
             <a:endParaRPr lang="en-US"/>
           </a:p>
@@ -569,10 +581,9 @@
           <a:lstStyle/>
           <a:p>
             <a:r>
-              <a:rPr lang="en-US" smtClean="0"/>
+              <a:rPr lang="en-US"/>
               <a:t>Click to edit Master title style</a:t>
             </a:r>
-            <a:endParaRPr lang="en-US"/>
           </a:p>
         </p:txBody>
       </p:sp>
@@ -598,38 +609,37 @@
           <a:p>
             <a:pPr lvl="0"/>
             <a:r>
-              <a:rPr lang="en-US" smtClean="0"/>
+              <a:rPr lang="en-US"/>
               <a:t>Click to edit Master text styles</a:t>
             </a:r>
           </a:p>
           <a:p>
             <a:pPr lvl="1"/>
             <a:r>
-              <a:rPr lang="en-US" smtClean="0"/>
+              <a:rPr lang="en-US"/>
               <a:t>Second level</a:t>
             </a:r>
           </a:p>
           <a:p>
             <a:pPr lvl="2"/>
             <a:r>
-              <a:rPr lang="en-US" smtClean="0"/>
+              <a:rPr lang="en-US"/>
               <a:t>Third level</a:t>
             </a:r>
           </a:p>
           <a:p>
             <a:pPr lvl="3"/>
             <a:r>
-              <a:rPr lang="en-US" smtClean="0"/>
+              <a:rPr lang="en-US"/>
               <a:t>Fourth level</a:t>
             </a:r>
           </a:p>
           <a:p>
             <a:pPr lvl="4"/>
             <a:r>
-              <a:rPr lang="en-US" smtClean="0"/>
+              <a:rPr lang="en-US"/>
               <a:t>Fifth level</a:t>
             </a:r>
-            <a:endParaRPr lang="en-US"/>
           </a:p>
         </p:txBody>
       </p:sp>
@@ -650,7 +660,7 @@
           <a:p>
             <a:fld id="{5BCAD085-E8A6-8845-BD4E-CB4CCA059FC4}" type="datetimeFigureOut">
               <a:rPr lang="en-US" smtClean="0"/>
-              <a:t>1/27/13</a:t>
+              <a:t>6/3/2026</a:t>
             </a:fld>
             <a:endParaRPr lang="en-US"/>
           </a:p>
@@ -744,10 +754,9 @@
           <a:lstStyle/>
           <a:p>
             <a:r>
-              <a:rPr lang="en-US" smtClean="0"/>
+              <a:rPr lang="en-US"/>
               <a:t>Click to edit Master title style</a:t>
             </a:r>
-            <a:endParaRPr lang="en-US"/>
           </a:p>
         </p:txBody>
       </p:sp>
@@ -768,38 +777,37 @@
           <a:p>
             <a:pPr lvl="0"/>
             <a:r>
-              <a:rPr lang="en-US" smtClean="0"/>
+              <a:rPr lang="en-US"/>
               <a:t>Click to edit Master text styles</a:t>
             </a:r>
           </a:p>
           <a:p>
             <a:pPr lvl="1"/>
             <a:r>
-              <a:rPr lang="en-US" smtClean="0"/>
+              <a:rPr lang="en-US"/>
               <a:t>Second level</a:t>
             </a:r>
           </a:p>
           <a:p>
             <a:pPr lvl="2"/>
             <a:r>
-              <a:rPr lang="en-US" smtClean="0"/>
+              <a:rPr lang="en-US"/>
               <a:t>Third level</a:t>
             </a:r>
           </a:p>
           <a:p>
             <a:pPr lvl="3"/>
             <a:r>
-              <a:rPr lang="en-US" smtClean="0"/>
+              <a:rPr lang="en-US"/>
               <a:t>Fourth level</a:t>
             </a:r>
           </a:p>
           <a:p>
             <a:pPr lvl="4"/>
             <a:r>
-              <a:rPr lang="en-US" smtClean="0"/>
+              <a:rPr lang="en-US"/>
               <a:t>Fifth level</a:t>
             </a:r>
-            <a:endParaRPr lang="en-US"/>
           </a:p>
         </p:txBody>
       </p:sp>
@@ -820,7 +828,7 @@
           <a:p>
             <a:fld id="{5BCAD085-E8A6-8845-BD4E-CB4CCA059FC4}" type="datetimeFigureOut">
               <a:rPr lang="en-US" smtClean="0"/>
-              <a:t>1/27/13</a:t>
+              <a:t>6/3/2026</a:t>
             </a:fld>
             <a:endParaRPr lang="en-US"/>
           </a:p>
@@ -923,10 +931,9 @@
           </a:lstStyle>
           <a:p>
             <a:r>
-              <a:rPr lang="en-US" smtClean="0"/>
+              <a:rPr lang="en-US"/>
               <a:t>Click to edit Master title style</a:t>
             </a:r>
-            <a:endParaRPr lang="en-US"/>
           </a:p>
         </p:txBody>
       </p:sp>
@@ -1043,7 +1050,7 @@
           <a:p>
             <a:pPr lvl="0"/>
             <a:r>
-              <a:rPr lang="en-US" smtClean="0"/>
+              <a:rPr lang="en-US"/>
               <a:t>Click to edit Master text styles</a:t>
             </a:r>
           </a:p>
@@ -1066,7 +1073,7 @@
           <a:p>
             <a:fld id="{5BCAD085-E8A6-8845-BD4E-CB4CCA059FC4}" type="datetimeFigureOut">
               <a:rPr lang="en-US" smtClean="0"/>
-              <a:t>1/27/13</a:t>
+              <a:t>6/3/2026</a:t>
             </a:fld>
             <a:endParaRPr lang="en-US"/>
           </a:p>
@@ -1160,10 +1167,9 @@
           <a:lstStyle/>
           <a:p>
             <a:r>
-              <a:rPr lang="en-US" smtClean="0"/>
+              <a:rPr lang="en-US"/>
               <a:t>Click to edit Master title style</a:t>
             </a:r>
-            <a:endParaRPr lang="en-US"/>
           </a:p>
         </p:txBody>
       </p:sp>
@@ -1217,38 +1223,37 @@
           <a:p>
             <a:pPr lvl="0"/>
             <a:r>
-              <a:rPr lang="en-US" smtClean="0"/>
+              <a:rPr lang="en-US"/>
               <a:t>Click to edit Master text styles</a:t>
             </a:r>
           </a:p>
           <a:p>
             <a:pPr lvl="1"/>
             <a:r>
-              <a:rPr lang="en-US" smtClean="0"/>
+              <a:rPr lang="en-US"/>
               <a:t>Second level</a:t>
             </a:r>
           </a:p>
           <a:p>
             <a:pPr lvl="2"/>
             <a:r>
-              <a:rPr lang="en-US" smtClean="0"/>
+              <a:rPr lang="en-US"/>
               <a:t>Third level</a:t>
             </a:r>
           </a:p>
           <a:p>
             <a:pPr lvl="3"/>
             <a:r>
-              <a:rPr lang="en-US" smtClean="0"/>
+              <a:rPr lang="en-US"/>
               <a:t>Fourth level</a:t>
             </a:r>
           </a:p>
           <a:p>
             <a:pPr lvl="4"/>
             <a:r>
-              <a:rPr lang="en-US" smtClean="0"/>
+              <a:rPr lang="en-US"/>
               <a:t>Fifth level</a:t>
             </a:r>
-            <a:endParaRPr lang="en-US"/>
           </a:p>
         </p:txBody>
       </p:sp>
@@ -1302,38 +1307,37 @@
           <a:p>
             <a:pPr lvl="0"/>
             <a:r>
-              <a:rPr lang="en-US" smtClean="0"/>
+              <a:rPr lang="en-US"/>
               <a:t>Click to edit Master text styles</a:t>
             </a:r>
           </a:p>
           <a:p>
             <a:pPr lvl="1"/>
             <a:r>
-              <a:rPr lang="en-US" smtClean="0"/>
+              <a:rPr lang="en-US"/>
               <a:t>Second level</a:t>
             </a:r>
           </a:p>
           <a:p>
             <a:pPr lvl="2"/>
             <a:r>
-              <a:rPr lang="en-US" smtClean="0"/>
+              <a:rPr lang="en-US"/>
               <a:t>Third level</a:t>
             </a:r>
           </a:p>
           <a:p>
             <a:pPr lvl="3"/>
             <a:r>
-              <a:rPr lang="en-US" smtClean="0"/>
+              <a:rPr lang="en-US"/>
               <a:t>Fourth level</a:t>
             </a:r>
           </a:p>
           <a:p>
             <a:pPr lvl="4"/>
             <a:r>
-              <a:rPr lang="en-US" smtClean="0"/>
+              <a:rPr lang="en-US"/>
               <a:t>Fifth level</a:t>
             </a:r>
-            <a:endParaRPr lang="en-US"/>
           </a:p>
         </p:txBody>
       </p:sp>
@@ -1354,7 +1358,7 @@
           <a:p>
             <a:fld id="{5BCAD085-E8A6-8845-BD4E-CB4CCA059FC4}" type="datetimeFigureOut">
               <a:rPr lang="en-US" smtClean="0"/>
-              <a:t>1/27/13</a:t>
+              <a:t>6/3/2026</a:t>
             </a:fld>
             <a:endParaRPr lang="en-US"/>
           </a:p>
@@ -1452,10 +1456,9 @@
           </a:lstStyle>
           <a:p>
             <a:r>
-              <a:rPr lang="en-US" smtClean="0"/>
+              <a:rPr lang="en-US"/>
               <a:t>Click to edit Master title style</a:t>
             </a:r>
-            <a:endParaRPr lang="en-US"/>
           </a:p>
         </p:txBody>
       </p:sp>
@@ -1518,7 +1521,7 @@
           <a:p>
             <a:pPr lvl="0"/>
             <a:r>
-              <a:rPr lang="en-US" smtClean="0"/>
+              <a:rPr lang="en-US"/>
               <a:t>Click to edit Master text styles</a:t>
             </a:r>
           </a:p>
@@ -1574,38 +1577,37 @@
           <a:p>
             <a:pPr lvl="0"/>
             <a:r>
-              <a:rPr lang="en-US" smtClean="0"/>
+              <a:rPr lang="en-US"/>
               <a:t>Click to edit Master text styles</a:t>
             </a:r>
           </a:p>
           <a:p>
             <a:pPr lvl="1"/>
             <a:r>
-              <a:rPr lang="en-US" smtClean="0"/>
+              <a:rPr lang="en-US"/>
               <a:t>Second level</a:t>
             </a:r>
           </a:p>
           <a:p>
             <a:pPr lvl="2"/>
             <a:r>
-              <a:rPr lang="en-US" smtClean="0"/>
+              <a:rPr lang="en-US"/>
               <a:t>Third level</a:t>
             </a:r>
           </a:p>
           <a:p>
             <a:pPr lvl="3"/>
             <a:r>
-              <a:rPr lang="en-US" smtClean="0"/>
+              <a:rPr lang="en-US"/>
               <a:t>Fourth level</a:t>
             </a:r>
           </a:p>
           <a:p>
             <a:pPr lvl="4"/>
             <a:r>
-              <a:rPr lang="en-US" smtClean="0"/>
+              <a:rPr lang="en-US"/>
               <a:t>Fifth level</a:t>
             </a:r>
-            <a:endParaRPr lang="en-US"/>
           </a:p>
         </p:txBody>
       </p:sp>
@@ -1668,7 +1670,7 @@
           <a:p>
             <a:pPr lvl="0"/>
             <a:r>
-              <a:rPr lang="en-US" smtClean="0"/>
+              <a:rPr lang="en-US"/>
               <a:t>Click to edit Master text styles</a:t>
             </a:r>
           </a:p>
@@ -1724,38 +1726,37 @@
           <a:p>
             <a:pPr lvl="0"/>
             <a:r>
-              <a:rPr lang="en-US" smtClean="0"/>
+              <a:rPr lang="en-US"/>
               <a:t>Click to edit Master text styles</a:t>
             </a:r>
           </a:p>
           <a:p>
             <a:pPr lvl="1"/>
             <a:r>
-              <a:rPr lang="en-US" smtClean="0"/>
+              <a:rPr lang="en-US"/>
               <a:t>Second level</a:t>
             </a:r>
           </a:p>
           <a:p>
             <a:pPr lvl="2"/>
             <a:r>
-              <a:rPr lang="en-US" smtClean="0"/>
+              <a:rPr lang="en-US"/>
               <a:t>Third level</a:t>
             </a:r>
           </a:p>
           <a:p>
             <a:pPr lvl="3"/>
             <a:r>
-              <a:rPr lang="en-US" smtClean="0"/>
+              <a:rPr lang="en-US"/>
               <a:t>Fourth level</a:t>
             </a:r>
           </a:p>
           <a:p>
             <a:pPr lvl="4"/>
             <a:r>
-              <a:rPr lang="en-US" smtClean="0"/>
+              <a:rPr lang="en-US"/>
               <a:t>Fifth level</a:t>
             </a:r>
-            <a:endParaRPr lang="en-US"/>
           </a:p>
         </p:txBody>
       </p:sp>
@@ -1776,7 +1777,7 @@
           <a:p>
             <a:fld id="{5BCAD085-E8A6-8845-BD4E-CB4CCA059FC4}" type="datetimeFigureOut">
               <a:rPr lang="en-US" smtClean="0"/>
-              <a:t>1/27/13</a:t>
+              <a:t>6/3/2026</a:t>
             </a:fld>
             <a:endParaRPr lang="en-US"/>
           </a:p>
@@ -1870,10 +1871,9 @@
           <a:lstStyle/>
           <a:p>
             <a:r>
-              <a:rPr lang="en-US" smtClean="0"/>
+              <a:rPr lang="en-US"/>
               <a:t>Click to edit Master title style</a:t>
             </a:r>
-            <a:endParaRPr lang="en-US"/>
           </a:p>
         </p:txBody>
       </p:sp>
@@ -1894,7 +1894,7 @@
           <a:p>
             <a:fld id="{5BCAD085-E8A6-8845-BD4E-CB4CCA059FC4}" type="datetimeFigureOut">
               <a:rPr lang="en-US" smtClean="0"/>
-              <a:t>1/27/13</a:t>
+              <a:t>6/3/2026</a:t>
             </a:fld>
             <a:endParaRPr lang="en-US"/>
           </a:p>
@@ -1989,7 +1989,7 @@
           <a:p>
             <a:fld id="{5BCAD085-E8A6-8845-BD4E-CB4CCA059FC4}" type="datetimeFigureOut">
               <a:rPr lang="en-US" smtClean="0"/>
-              <a:t>1/27/13</a:t>
+              <a:t>6/3/2026</a:t>
             </a:fld>
             <a:endParaRPr lang="en-US"/>
           </a:p>
@@ -2092,10 +2092,9 @@
           </a:lstStyle>
           <a:p>
             <a:r>
-              <a:rPr lang="en-US" smtClean="0"/>
+              <a:rPr lang="en-US"/>
               <a:t>Click to edit Master title style</a:t>
             </a:r>
-            <a:endParaRPr lang="en-US"/>
           </a:p>
         </p:txBody>
       </p:sp>
@@ -2149,38 +2148,37 @@
           <a:p>
             <a:pPr lvl="0"/>
             <a:r>
-              <a:rPr lang="en-US" smtClean="0"/>
+              <a:rPr lang="en-US"/>
               <a:t>Click to edit Master text styles</a:t>
             </a:r>
           </a:p>
           <a:p>
             <a:pPr lvl="1"/>
             <a:r>
-              <a:rPr lang="en-US" smtClean="0"/>
+              <a:rPr lang="en-US"/>
               <a:t>Second level</a:t>
             </a:r>
           </a:p>
           <a:p>
             <a:pPr lvl="2"/>
             <a:r>
-              <a:rPr lang="en-US" smtClean="0"/>
+              <a:rPr lang="en-US"/>
               <a:t>Third level</a:t>
             </a:r>
           </a:p>
           <a:p>
             <a:pPr lvl="3"/>
             <a:r>
-              <a:rPr lang="en-US" smtClean="0"/>
+              <a:rPr lang="en-US"/>
               <a:t>Fourth level</a:t>
             </a:r>
           </a:p>
           <a:p>
             <a:pPr lvl="4"/>
             <a:r>
-              <a:rPr lang="en-US" smtClean="0"/>
+              <a:rPr lang="en-US"/>
               <a:t>Fifth level</a:t>
             </a:r>
-            <a:endParaRPr lang="en-US"/>
           </a:p>
         </p:txBody>
       </p:sp>
@@ -2243,7 +2241,7 @@
           <a:p>
             <a:pPr lvl="0"/>
             <a:r>
-              <a:rPr lang="en-US" smtClean="0"/>
+              <a:rPr lang="en-US"/>
               <a:t>Click to edit Master text styles</a:t>
             </a:r>
           </a:p>
@@ -2266,7 +2264,7 @@
           <a:p>
             <a:fld id="{5BCAD085-E8A6-8845-BD4E-CB4CCA059FC4}" type="datetimeFigureOut">
               <a:rPr lang="en-US" smtClean="0"/>
-              <a:t>1/27/13</a:t>
+              <a:t>6/3/2026</a:t>
             </a:fld>
             <a:endParaRPr lang="en-US"/>
           </a:p>
@@ -2369,10 +2367,9 @@
           </a:lstStyle>
           <a:p>
             <a:r>
-              <a:rPr lang="en-US" smtClean="0"/>
+              <a:rPr lang="en-US"/>
               <a:t>Click to edit Master title style</a:t>
             </a:r>
-            <a:endParaRPr lang="en-US"/>
           </a:p>
         </p:txBody>
       </p:sp>
@@ -2496,7 +2493,7 @@
           <a:p>
             <a:pPr lvl="0"/>
             <a:r>
-              <a:rPr lang="en-US" smtClean="0"/>
+              <a:rPr lang="en-US"/>
               <a:t>Click to edit Master text styles</a:t>
             </a:r>
           </a:p>
@@ -2519,7 +2516,7 @@
           <a:p>
             <a:fld id="{5BCAD085-E8A6-8845-BD4E-CB4CCA059FC4}" type="datetimeFigureOut">
               <a:rPr lang="en-US" smtClean="0"/>
-              <a:t>1/27/13</a:t>
+              <a:t>6/3/2026</a:t>
             </a:fld>
             <a:endParaRPr lang="en-US"/>
           </a:p>
@@ -2628,10 +2625,9 @@
           <a:lstStyle/>
           <a:p>
             <a:r>
-              <a:rPr lang="en-US" smtClean="0"/>
+              <a:rPr lang="en-US"/>
               <a:t>Click to edit Master title style</a:t>
             </a:r>
-            <a:endParaRPr lang="en-US"/>
           </a:p>
         </p:txBody>
       </p:sp>
@@ -2662,38 +2658,37 @@
           <a:p>
             <a:pPr lvl="0"/>
             <a:r>
-              <a:rPr lang="en-US" smtClean="0"/>
+              <a:rPr lang="en-US"/>
               <a:t>Click to edit Master text styles</a:t>
             </a:r>
           </a:p>
           <a:p>
             <a:pPr lvl="1"/>
             <a:r>
-              <a:rPr lang="en-US" smtClean="0"/>
+              <a:rPr lang="en-US"/>
               <a:t>Second level</a:t>
             </a:r>
           </a:p>
           <a:p>
             <a:pPr lvl="2"/>
             <a:r>
-              <a:rPr lang="en-US" smtClean="0"/>
+              <a:rPr lang="en-US"/>
               <a:t>Third level</a:t>
             </a:r>
           </a:p>
           <a:p>
             <a:pPr lvl="3"/>
             <a:r>
-              <a:rPr lang="en-US" smtClean="0"/>
+              <a:rPr lang="en-US"/>
               <a:t>Fourth level</a:t>
             </a:r>
           </a:p>
           <a:p>
             <a:pPr lvl="4"/>
             <a:r>
-              <a:rPr lang="en-US" smtClean="0"/>
+              <a:rPr lang="en-US"/>
               <a:t>Fifth level</a:t>
             </a:r>
-            <a:endParaRPr lang="en-US"/>
           </a:p>
         </p:txBody>
       </p:sp>
@@ -2732,7 +2727,7 @@
           <a:p>
             <a:fld id="{5BCAD085-E8A6-8845-BD4E-CB4CCA059FC4}" type="datetimeFigureOut">
               <a:rPr lang="en-US" smtClean="0"/>
-              <a:t>1/27/13</a:t>
+              <a:t>6/3/2026</a:t>
             </a:fld>
             <a:endParaRPr lang="en-US"/>
           </a:p>
@@ -3091,7 +3086,7 @@
 </file>
 
 <file path=ppt/slides/slide1.xml><?xml version="1.0" encoding="utf-8"?>
-<p:sld xmlns:a="http://schemas.openxmlformats.org/drawingml/2006/main" xmlns:p="http://schemas.openxmlformats.org/presentationml/2006/main" xmlns:r="http://schemas.openxmlformats.org/officeDocument/2006/relationships">
+<p:sld xmlns:a="http://schemas.openxmlformats.org/drawingml/2006/main" xmlns:r="http://schemas.openxmlformats.org/officeDocument/2006/relationships" xmlns:p="http://schemas.openxmlformats.org/presentationml/2006/main">
   <p:cSld>
     <p:spTree>
       <p:nvGrpSpPr>
@@ -3099,7 +3094,14 @@
         <p:cNvGrpSpPr/>
         <p:nvPr/>
       </p:nvGrpSpPr>
-      <p:grpSpPr/>
+      <p:grpSpPr>
+        <a:xfrm>
+          <a:off x="0" y="0"/>
+          <a:ext cx="0" cy="0"/>
+          <a:chOff x="0" y="0"/>
+          <a:chExt cx="0" cy="0"/>
+        </a:xfrm>
+      </p:grpSpPr>
       <p:sp>
         <p:nvSpPr>
           <p:cNvPr id="2" name="Rectangle 1"/>
@@ -3141,6 +3143,7 @@
           <a:lstStyle/>
           <a:p>
             <a:pPr algn="ctr"/>
+            <a:endParaRPr/>
           </a:p>
         </p:txBody>
       </p:sp>
@@ -3186,6 +3189,7 @@
           <a:lstStyle/>
           <a:p>
             <a:pPr algn="ctr"/>
+            <a:endParaRPr/>
           </a:p>
         </p:txBody>
       </p:sp>
@@ -3231,6 +3235,7 @@
           <a:lstStyle/>
           <a:p>
             <a:pPr algn="ctr"/>
+            <a:endParaRPr/>
           </a:p>
         </p:txBody>
       </p:sp>
@@ -3274,6 +3279,7 @@
           <a:lstStyle/>
           <a:p>
             <a:pPr algn="ctr"/>
+            <a:endParaRPr/>
           </a:p>
         </p:txBody>
       </p:sp>
@@ -3294,7 +3300,7 @@
           <a:noFill/>
         </p:spPr>
         <p:txBody>
-          <a:bodyPr wrap="square" lIns="0" rIns="0" tIns="0" bIns="0" anchor="t">
+          <a:bodyPr wrap="square" lIns="0" tIns="0" rIns="0" bIns="0" anchor="t">
             <a:spAutoFit/>
           </a:bodyPr>
           <a:lstStyle/>
@@ -3329,7 +3335,7 @@
           <a:noFill/>
         </p:spPr>
         <p:txBody>
-          <a:bodyPr wrap="square" lIns="0" rIns="0" tIns="0" bIns="0" anchor="t">
+          <a:bodyPr wrap="square" lIns="0" tIns="0" rIns="0" bIns="0" anchor="t">
             <a:spAutoFit/>
           </a:bodyPr>
           <a:lstStyle/>
@@ -3364,7 +3370,7 @@
           <a:noFill/>
         </p:spPr>
         <p:txBody>
-          <a:bodyPr wrap="square" lIns="0" rIns="0" tIns="0" bIns="0" anchor="t">
+          <a:bodyPr wrap="square" lIns="0" tIns="0" rIns="0" bIns="0" anchor="t">
             <a:spAutoFit/>
           </a:bodyPr>
           <a:lstStyle/>
@@ -3399,7 +3405,7 @@
           <a:noFill/>
         </p:spPr>
         <p:txBody>
-          <a:bodyPr wrap="square" lIns="0" rIns="0" tIns="0" bIns="0" anchor="t">
+          <a:bodyPr wrap="square" lIns="0" tIns="0" rIns="0" bIns="0" anchor="t">
             <a:spAutoFit/>
           </a:bodyPr>
           <a:lstStyle/>
@@ -3426,7 +3432,7 @@
 </file>
 
 <file path=ppt/slides/slide10.xml><?xml version="1.0" encoding="utf-8"?>
-<p:sld xmlns:a="http://schemas.openxmlformats.org/drawingml/2006/main" xmlns:p="http://schemas.openxmlformats.org/presentationml/2006/main" xmlns:r="http://schemas.openxmlformats.org/officeDocument/2006/relationships">
+<p:sld xmlns:a="http://schemas.openxmlformats.org/drawingml/2006/main" xmlns:r="http://schemas.openxmlformats.org/officeDocument/2006/relationships" xmlns:p="http://schemas.openxmlformats.org/presentationml/2006/main">
   <p:cSld>
     <p:spTree>
       <p:nvGrpSpPr>
@@ -3434,7 +3440,14 @@
         <p:cNvGrpSpPr/>
         <p:nvPr/>
       </p:nvGrpSpPr>
-      <p:grpSpPr/>
+      <p:grpSpPr>
+        <a:xfrm>
+          <a:off x="0" y="0"/>
+          <a:ext cx="0" cy="0"/>
+          <a:chOff x="0" y="0"/>
+          <a:chExt cx="0" cy="0"/>
+        </a:xfrm>
+      </p:grpSpPr>
       <p:sp>
         <p:nvSpPr>
           <p:cNvPr id="2" name="Rectangle 1"/>
@@ -3476,6 +3489,7 @@
           <a:lstStyle/>
           <a:p>
             <a:pPr algn="ctr"/>
+            <a:endParaRPr/>
           </a:p>
         </p:txBody>
       </p:sp>
@@ -3521,6 +3535,7 @@
           <a:lstStyle/>
           <a:p>
             <a:pPr algn="ctr"/>
+            <a:endParaRPr/>
           </a:p>
         </p:txBody>
       </p:sp>
@@ -3566,6 +3581,7 @@
           <a:lstStyle/>
           <a:p>
             <a:pPr algn="ctr"/>
+            <a:endParaRPr/>
           </a:p>
         </p:txBody>
       </p:sp>
@@ -3609,6 +3625,7 @@
           <a:lstStyle/>
           <a:p>
             <a:pPr algn="ctr"/>
+            <a:endParaRPr/>
           </a:p>
         </p:txBody>
       </p:sp>
@@ -3629,7 +3646,7 @@
           <a:noFill/>
         </p:spPr>
         <p:txBody>
-          <a:bodyPr wrap="square" lIns="0" rIns="0" tIns="0" bIns="0" anchor="t">
+          <a:bodyPr wrap="square" lIns="0" tIns="0" rIns="0" bIns="0" anchor="t">
             <a:spAutoFit/>
           </a:bodyPr>
           <a:lstStyle/>
@@ -3664,7 +3681,7 @@
           <a:noFill/>
         </p:spPr>
         <p:txBody>
-          <a:bodyPr wrap="square" lIns="0" rIns="0" tIns="0" bIns="0" anchor="t">
+          <a:bodyPr wrap="square" lIns="0" tIns="0" rIns="0" bIns="0" anchor="t">
             <a:spAutoFit/>
           </a:bodyPr>
           <a:lstStyle/>
@@ -3729,6 +3746,7 @@
           <a:lstStyle/>
           <a:p>
             <a:pPr algn="ctr"/>
+            <a:endParaRPr/>
           </a:p>
         </p:txBody>
       </p:sp>
@@ -3749,7 +3767,7 @@
           <a:noFill/>
         </p:spPr>
         <p:txBody>
-          <a:bodyPr wrap="square" lIns="0" rIns="0" tIns="0" bIns="0" anchor="t">
+          <a:bodyPr wrap="square" lIns="0" tIns="0" rIns="0" bIns="0" anchor="t">
             <a:spAutoFit/>
           </a:bodyPr>
           <a:lstStyle/>
@@ -3784,7 +3802,7 @@
           <a:noFill/>
         </p:spPr>
         <p:txBody>
-          <a:bodyPr wrap="square" lIns="0" rIns="0" tIns="0" bIns="0" anchor="t">
+          <a:bodyPr wrap="square" lIns="0" tIns="0" rIns="0" bIns="0" anchor="t">
             <a:spAutoFit/>
           </a:bodyPr>
           <a:lstStyle/>
@@ -3849,6 +3867,7 @@
           <a:lstStyle/>
           <a:p>
             <a:pPr algn="ctr"/>
+            <a:endParaRPr/>
           </a:p>
         </p:txBody>
       </p:sp>
@@ -3869,7 +3888,7 @@
           <a:noFill/>
         </p:spPr>
         <p:txBody>
-          <a:bodyPr wrap="square" lIns="0" rIns="0" tIns="0" bIns="0" anchor="t">
+          <a:bodyPr wrap="square" lIns="0" tIns="0" rIns="0" bIns="0" anchor="t">
             <a:spAutoFit/>
           </a:bodyPr>
           <a:lstStyle/>
@@ -3904,7 +3923,7 @@
           <a:noFill/>
         </p:spPr>
         <p:txBody>
-          <a:bodyPr wrap="square" lIns="0" rIns="0" tIns="0" bIns="0" anchor="t">
+          <a:bodyPr wrap="square" lIns="0" tIns="0" rIns="0" bIns="0" anchor="t">
             <a:spAutoFit/>
           </a:bodyPr>
           <a:lstStyle/>
@@ -3969,6 +3988,7 @@
           <a:lstStyle/>
           <a:p>
             <a:pPr algn="ctr"/>
+            <a:endParaRPr/>
           </a:p>
         </p:txBody>
       </p:sp>
@@ -3989,7 +4009,7 @@
           <a:noFill/>
         </p:spPr>
         <p:txBody>
-          <a:bodyPr wrap="square" lIns="0" rIns="0" tIns="0" bIns="0" anchor="t">
+          <a:bodyPr wrap="square" lIns="0" tIns="0" rIns="0" bIns="0" anchor="t">
             <a:spAutoFit/>
           </a:bodyPr>
           <a:lstStyle/>
@@ -4024,7 +4044,7 @@
           <a:noFill/>
         </p:spPr>
         <p:txBody>
-          <a:bodyPr wrap="square" lIns="0" rIns="0" tIns="0" bIns="0" anchor="t">
+          <a:bodyPr wrap="square" lIns="0" tIns="0" rIns="0" bIns="0" anchor="t">
             <a:spAutoFit/>
           </a:bodyPr>
           <a:lstStyle/>
@@ -4059,7 +4079,7 @@
           <a:noFill/>
         </p:spPr>
         <p:txBody>
-          <a:bodyPr wrap="square" lIns="0" rIns="0" tIns="0" bIns="0" anchor="t">
+          <a:bodyPr wrap="square" lIns="0" tIns="0" rIns="0" bIns="0" anchor="t">
             <a:spAutoFit/>
           </a:bodyPr>
           <a:lstStyle/>
@@ -4086,7 +4106,7 @@
 </file>
 
 <file path=ppt/slides/slide11.xml><?xml version="1.0" encoding="utf-8"?>
-<p:sld xmlns:a="http://schemas.openxmlformats.org/drawingml/2006/main" xmlns:p="http://schemas.openxmlformats.org/presentationml/2006/main" xmlns:r="http://schemas.openxmlformats.org/officeDocument/2006/relationships">
+<p:sld xmlns:a="http://schemas.openxmlformats.org/drawingml/2006/main" xmlns:r="http://schemas.openxmlformats.org/officeDocument/2006/relationships" xmlns:p="http://schemas.openxmlformats.org/presentationml/2006/main">
   <p:cSld>
     <p:spTree>
       <p:nvGrpSpPr>
@@ -4094,7 +4114,14 @@
         <p:cNvGrpSpPr/>
         <p:nvPr/>
       </p:nvGrpSpPr>
-      <p:grpSpPr/>
+      <p:grpSpPr>
+        <a:xfrm>
+          <a:off x="0" y="0"/>
+          <a:ext cx="0" cy="0"/>
+          <a:chOff x="0" y="0"/>
+          <a:chExt cx="0" cy="0"/>
+        </a:xfrm>
+      </p:grpSpPr>
       <p:sp>
         <p:nvSpPr>
           <p:cNvPr id="2" name="Rectangle 1"/>
@@ -4136,6 +4163,7 @@
           <a:lstStyle/>
           <a:p>
             <a:pPr algn="ctr"/>
+            <a:endParaRPr/>
           </a:p>
         </p:txBody>
       </p:sp>
@@ -4181,6 +4209,7 @@
           <a:lstStyle/>
           <a:p>
             <a:pPr algn="ctr"/>
+            <a:endParaRPr/>
           </a:p>
         </p:txBody>
       </p:sp>
@@ -4226,6 +4255,7 @@
           <a:lstStyle/>
           <a:p>
             <a:pPr algn="ctr"/>
+            <a:endParaRPr/>
           </a:p>
         </p:txBody>
       </p:sp>
@@ -4269,6 +4299,7 @@
           <a:lstStyle/>
           <a:p>
             <a:pPr algn="ctr"/>
+            <a:endParaRPr/>
           </a:p>
         </p:txBody>
       </p:sp>
@@ -4289,7 +4320,7 @@
           <a:noFill/>
         </p:spPr>
         <p:txBody>
-          <a:bodyPr wrap="square" lIns="0" rIns="0" tIns="0" bIns="0" anchor="t">
+          <a:bodyPr wrap="square" lIns="0" tIns="0" rIns="0" bIns="0" anchor="t">
             <a:spAutoFit/>
           </a:bodyPr>
           <a:lstStyle/>
@@ -4324,7 +4355,7 @@
           <a:noFill/>
         </p:spPr>
         <p:txBody>
-          <a:bodyPr wrap="square" lIns="0" rIns="0" tIns="0" bIns="0" anchor="t">
+          <a:bodyPr wrap="square" lIns="0" tIns="0" rIns="0" bIns="0" anchor="t">
             <a:spAutoFit/>
           </a:bodyPr>
           <a:lstStyle/>
@@ -4359,7 +4390,7 @@
           <a:noFill/>
         </p:spPr>
         <p:txBody>
-          <a:bodyPr wrap="square" lIns="0" rIns="0" tIns="0" bIns="0">
+          <a:bodyPr wrap="square" lIns="0" tIns="0" rIns="0" bIns="0">
             <a:spAutoFit/>
           </a:bodyPr>
           <a:lstStyle/>
@@ -4514,7 +4545,7 @@
 </file>
 
 <file path=ppt/slides/slide12.xml><?xml version="1.0" encoding="utf-8"?>
-<p:sld xmlns:a="http://schemas.openxmlformats.org/drawingml/2006/main" xmlns:p="http://schemas.openxmlformats.org/presentationml/2006/main" xmlns:r="http://schemas.openxmlformats.org/officeDocument/2006/relationships">
+<p:sld xmlns:a="http://schemas.openxmlformats.org/drawingml/2006/main" xmlns:r="http://schemas.openxmlformats.org/officeDocument/2006/relationships" xmlns:p="http://schemas.openxmlformats.org/presentationml/2006/main">
   <p:cSld>
     <p:spTree>
       <p:nvGrpSpPr>
@@ -4522,7 +4553,14 @@
         <p:cNvGrpSpPr/>
         <p:nvPr/>
       </p:nvGrpSpPr>
-      <p:grpSpPr/>
+      <p:grpSpPr>
+        <a:xfrm>
+          <a:off x="0" y="0"/>
+          <a:ext cx="0" cy="0"/>
+          <a:chOff x="0" y="0"/>
+          <a:chExt cx="0" cy="0"/>
+        </a:xfrm>
+      </p:grpSpPr>
       <p:sp>
         <p:nvSpPr>
           <p:cNvPr id="2" name="Rectangle 1"/>
@@ -4564,6 +4602,7 @@
           <a:lstStyle/>
           <a:p>
             <a:pPr algn="ctr"/>
+            <a:endParaRPr/>
           </a:p>
         </p:txBody>
       </p:sp>
@@ -4609,6 +4648,7 @@
           <a:lstStyle/>
           <a:p>
             <a:pPr algn="ctr"/>
+            <a:endParaRPr/>
           </a:p>
         </p:txBody>
       </p:sp>
@@ -4654,6 +4694,7 @@
           <a:lstStyle/>
           <a:p>
             <a:pPr algn="ctr"/>
+            <a:endParaRPr/>
           </a:p>
         </p:txBody>
       </p:sp>
@@ -4697,6 +4738,7 @@
           <a:lstStyle/>
           <a:p>
             <a:pPr algn="ctr"/>
+            <a:endParaRPr/>
           </a:p>
         </p:txBody>
       </p:sp>
@@ -4717,7 +4759,7 @@
           <a:noFill/>
         </p:spPr>
         <p:txBody>
-          <a:bodyPr wrap="square" lIns="0" rIns="0" tIns="0" bIns="0" anchor="t">
+          <a:bodyPr wrap="square" lIns="0" tIns="0" rIns="0" bIns="0" anchor="t">
             <a:spAutoFit/>
           </a:bodyPr>
           <a:lstStyle/>
@@ -4752,7 +4794,7 @@
           <a:noFill/>
         </p:spPr>
         <p:txBody>
-          <a:bodyPr wrap="square" lIns="0" rIns="0" tIns="0" bIns="0" anchor="t">
+          <a:bodyPr wrap="square" lIns="0" tIns="0" rIns="0" bIns="0" anchor="t">
             <a:spAutoFit/>
           </a:bodyPr>
           <a:lstStyle/>
@@ -4787,7 +4829,7 @@
           <a:noFill/>
         </p:spPr>
         <p:txBody>
-          <a:bodyPr wrap="square" lIns="0" rIns="0" tIns="0" bIns="0">
+          <a:bodyPr wrap="square" lIns="0" tIns="0" rIns="0" bIns="0">
             <a:spAutoFit/>
           </a:bodyPr>
           <a:lstStyle/>
@@ -4914,7 +4956,7 @@
 </file>
 
 <file path=ppt/slides/slide13.xml><?xml version="1.0" encoding="utf-8"?>
-<p:sld xmlns:a="http://schemas.openxmlformats.org/drawingml/2006/main" xmlns:p="http://schemas.openxmlformats.org/presentationml/2006/main" xmlns:r="http://schemas.openxmlformats.org/officeDocument/2006/relationships">
+<p:sld xmlns:a="http://schemas.openxmlformats.org/drawingml/2006/main" xmlns:r="http://schemas.openxmlformats.org/officeDocument/2006/relationships" xmlns:p="http://schemas.openxmlformats.org/presentationml/2006/main">
   <p:cSld>
     <p:spTree>
       <p:nvGrpSpPr>
@@ -4922,7 +4964,14 @@
         <p:cNvGrpSpPr/>
         <p:nvPr/>
       </p:nvGrpSpPr>
-      <p:grpSpPr/>
+      <p:grpSpPr>
+        <a:xfrm>
+          <a:off x="0" y="0"/>
+          <a:ext cx="0" cy="0"/>
+          <a:chOff x="0" y="0"/>
+          <a:chExt cx="0" cy="0"/>
+        </a:xfrm>
+      </p:grpSpPr>
       <p:sp>
         <p:nvSpPr>
           <p:cNvPr id="2" name="Rectangle 1"/>
@@ -4964,6 +5013,7 @@
           <a:lstStyle/>
           <a:p>
             <a:pPr algn="ctr"/>
+            <a:endParaRPr/>
           </a:p>
         </p:txBody>
       </p:sp>
@@ -5009,6 +5059,7 @@
           <a:lstStyle/>
           <a:p>
             <a:pPr algn="ctr"/>
+            <a:endParaRPr/>
           </a:p>
         </p:txBody>
       </p:sp>
@@ -5054,6 +5105,7 @@
           <a:lstStyle/>
           <a:p>
             <a:pPr algn="ctr"/>
+            <a:endParaRPr/>
           </a:p>
         </p:txBody>
       </p:sp>
@@ -5097,6 +5149,7 @@
           <a:lstStyle/>
           <a:p>
             <a:pPr algn="ctr"/>
+            <a:endParaRPr/>
           </a:p>
         </p:txBody>
       </p:sp>
@@ -5117,7 +5170,7 @@
           <a:noFill/>
         </p:spPr>
         <p:txBody>
-          <a:bodyPr wrap="square" lIns="0" rIns="0" tIns="0" bIns="0" anchor="t">
+          <a:bodyPr wrap="square" lIns="0" tIns="0" rIns="0" bIns="0" anchor="t">
             <a:spAutoFit/>
           </a:bodyPr>
           <a:lstStyle/>
@@ -5152,7 +5205,7 @@
           <a:noFill/>
         </p:spPr>
         <p:txBody>
-          <a:bodyPr wrap="square" lIns="0" rIns="0" tIns="0" bIns="0" anchor="t">
+          <a:bodyPr wrap="square" lIns="0" tIns="0" rIns="0" bIns="0" anchor="t">
             <a:spAutoFit/>
           </a:bodyPr>
           <a:lstStyle/>
@@ -5187,7 +5240,7 @@
           <a:noFill/>
         </p:spPr>
         <p:txBody>
-          <a:bodyPr wrap="square" lIns="0" rIns="0" tIns="0" bIns="0" anchor="t">
+          <a:bodyPr wrap="square" lIns="0" tIns="0" rIns="0" bIns="0" anchor="t">
             <a:spAutoFit/>
           </a:bodyPr>
           <a:lstStyle/>
@@ -5214,7 +5267,7 @@
 </file>
 
 <file path=ppt/slides/slide2.xml><?xml version="1.0" encoding="utf-8"?>
-<p:sld xmlns:a="http://schemas.openxmlformats.org/drawingml/2006/main" xmlns:p="http://schemas.openxmlformats.org/presentationml/2006/main" xmlns:r="http://schemas.openxmlformats.org/officeDocument/2006/relationships">
+<p:sld xmlns:a="http://schemas.openxmlformats.org/drawingml/2006/main" xmlns:r="http://schemas.openxmlformats.org/officeDocument/2006/relationships" xmlns:p="http://schemas.openxmlformats.org/presentationml/2006/main">
   <p:cSld>
     <p:spTree>
       <p:nvGrpSpPr>
@@ -5222,7 +5275,14 @@
         <p:cNvGrpSpPr/>
         <p:nvPr/>
       </p:nvGrpSpPr>
-      <p:grpSpPr/>
+      <p:grpSpPr>
+        <a:xfrm>
+          <a:off x="0" y="0"/>
+          <a:ext cx="0" cy="0"/>
+          <a:chOff x="0" y="0"/>
+          <a:chExt cx="0" cy="0"/>
+        </a:xfrm>
+      </p:grpSpPr>
       <p:sp>
         <p:nvSpPr>
           <p:cNvPr id="2" name="Rectangle 1"/>
@@ -5264,6 +5324,7 @@
           <a:lstStyle/>
           <a:p>
             <a:pPr algn="ctr"/>
+            <a:endParaRPr/>
           </a:p>
         </p:txBody>
       </p:sp>
@@ -5309,6 +5370,7 @@
           <a:lstStyle/>
           <a:p>
             <a:pPr algn="ctr"/>
+            <a:endParaRPr/>
           </a:p>
         </p:txBody>
       </p:sp>
@@ -5354,6 +5416,7 @@
           <a:lstStyle/>
           <a:p>
             <a:pPr algn="ctr"/>
+            <a:endParaRPr/>
           </a:p>
         </p:txBody>
       </p:sp>
@@ -5397,6 +5460,7 @@
           <a:lstStyle/>
           <a:p>
             <a:pPr algn="ctr"/>
+            <a:endParaRPr/>
           </a:p>
         </p:txBody>
       </p:sp>
@@ -5417,7 +5481,7 @@
           <a:noFill/>
         </p:spPr>
         <p:txBody>
-          <a:bodyPr wrap="square" lIns="0" rIns="0" tIns="0" bIns="0" anchor="t">
+          <a:bodyPr wrap="square" lIns="0" tIns="0" rIns="0" bIns="0" anchor="t">
             <a:spAutoFit/>
           </a:bodyPr>
           <a:lstStyle/>
@@ -5452,14 +5516,14 @@
           <a:noFill/>
         </p:spPr>
         <p:txBody>
-          <a:bodyPr wrap="square" lIns="0" rIns="0" tIns="0" bIns="0" anchor="t">
+          <a:bodyPr wrap="square" lIns="0" tIns="0" rIns="0" bIns="0" anchor="t">
             <a:spAutoFit/>
           </a:bodyPr>
           <a:lstStyle/>
           <a:p>
             <a:pPr algn="l"/>
             <a:r>
-              <a:rPr sz="2000" b="0">
+              <a:rPr sz="2000" b="0" dirty="0">
                 <a:solidFill>
                   <a:srgbClr val="9457FF"/>
                 </a:solidFill>
@@ -5487,7 +5551,7 @@
           <a:noFill/>
         </p:spPr>
         <p:txBody>
-          <a:bodyPr wrap="square" lIns="0" rIns="0" tIns="0" bIns="0">
+          <a:bodyPr wrap="square" lIns="0" tIns="0" rIns="0" bIns="0">
             <a:spAutoFit/>
           </a:bodyPr>
           <a:lstStyle/>
@@ -5501,7 +5565,7 @@
               </a:spcAft>
             </a:pPr>
             <a:r>
-              <a:rPr sz="2000">
+              <a:rPr sz="2000" dirty="0">
                 <a:solidFill>
                   <a:srgbClr val="9457FF"/>
                 </a:solidFill>
@@ -5510,7 +5574,7 @@
               <a:t>●  </a:t>
             </a:r>
             <a:r>
-              <a:rPr sz="2000">
+              <a:rPr sz="2000" dirty="0">
                 <a:solidFill>
                   <a:srgbClr val="EDEDF2"/>
                 </a:solidFill>
@@ -5529,7 +5593,7 @@
               </a:spcAft>
             </a:pPr>
             <a:r>
-              <a:rPr sz="2000">
+              <a:rPr sz="2000" dirty="0">
                 <a:solidFill>
                   <a:srgbClr val="9457FF"/>
                 </a:solidFill>
@@ -5538,7 +5602,7 @@
               <a:t>●  </a:t>
             </a:r>
             <a:r>
-              <a:rPr sz="2000">
+              <a:rPr sz="2000" dirty="0">
                 <a:solidFill>
                   <a:srgbClr val="EDEDF2"/>
                 </a:solidFill>
@@ -5557,7 +5621,7 @@
               </a:spcAft>
             </a:pPr>
             <a:r>
-              <a:rPr sz="2000">
+              <a:rPr sz="2000" dirty="0">
                 <a:solidFill>
                   <a:srgbClr val="9457FF"/>
                 </a:solidFill>
@@ -5566,7 +5630,7 @@
               <a:t>●  </a:t>
             </a:r>
             <a:r>
-              <a:rPr sz="2000">
+              <a:rPr sz="2000" dirty="0">
                 <a:solidFill>
                   <a:srgbClr val="EDEDF2"/>
                 </a:solidFill>
@@ -5585,7 +5649,7 @@
               </a:spcAft>
             </a:pPr>
             <a:r>
-              <a:rPr sz="2000">
+              <a:rPr sz="2000" dirty="0">
                 <a:solidFill>
                   <a:srgbClr val="9457FF"/>
                 </a:solidFill>
@@ -5594,7 +5658,7 @@
               <a:t>●  </a:t>
             </a:r>
             <a:r>
-              <a:rPr sz="2000">
+              <a:rPr sz="2000" dirty="0">
                 <a:solidFill>
                   <a:srgbClr val="EDEDF2"/>
                 </a:solidFill>
@@ -5614,7 +5678,7 @@
 </file>
 
 <file path=ppt/slides/slide3.xml><?xml version="1.0" encoding="utf-8"?>
-<p:sld xmlns:a="http://schemas.openxmlformats.org/drawingml/2006/main" xmlns:p="http://schemas.openxmlformats.org/presentationml/2006/main" xmlns:r="http://schemas.openxmlformats.org/officeDocument/2006/relationships">
+<p:sld xmlns:a="http://schemas.openxmlformats.org/drawingml/2006/main" xmlns:r="http://schemas.openxmlformats.org/officeDocument/2006/relationships" xmlns:p="http://schemas.openxmlformats.org/presentationml/2006/main">
   <p:cSld>
     <p:spTree>
       <p:nvGrpSpPr>
@@ -5622,7 +5686,14 @@
         <p:cNvGrpSpPr/>
         <p:nvPr/>
       </p:nvGrpSpPr>
-      <p:grpSpPr/>
+      <p:grpSpPr>
+        <a:xfrm>
+          <a:off x="0" y="0"/>
+          <a:ext cx="0" cy="0"/>
+          <a:chOff x="0" y="0"/>
+          <a:chExt cx="0" cy="0"/>
+        </a:xfrm>
+      </p:grpSpPr>
       <p:sp>
         <p:nvSpPr>
           <p:cNvPr id="2" name="Rectangle 1"/>
@@ -5664,6 +5735,7 @@
           <a:lstStyle/>
           <a:p>
             <a:pPr algn="ctr"/>
+            <a:endParaRPr/>
           </a:p>
         </p:txBody>
       </p:sp>
@@ -5709,6 +5781,7 @@
           <a:lstStyle/>
           <a:p>
             <a:pPr algn="ctr"/>
+            <a:endParaRPr/>
           </a:p>
         </p:txBody>
       </p:sp>
@@ -5754,6 +5827,7 @@
           <a:lstStyle/>
           <a:p>
             <a:pPr algn="ctr"/>
+            <a:endParaRPr/>
           </a:p>
         </p:txBody>
       </p:sp>
@@ -5797,6 +5871,7 @@
           <a:lstStyle/>
           <a:p>
             <a:pPr algn="ctr"/>
+            <a:endParaRPr/>
           </a:p>
         </p:txBody>
       </p:sp>
@@ -5817,7 +5892,7 @@
           <a:noFill/>
         </p:spPr>
         <p:txBody>
-          <a:bodyPr wrap="square" lIns="0" rIns="0" tIns="0" bIns="0" anchor="t">
+          <a:bodyPr wrap="square" lIns="0" tIns="0" rIns="0" bIns="0" anchor="t">
             <a:spAutoFit/>
           </a:bodyPr>
           <a:lstStyle/>
@@ -5852,14 +5927,14 @@
           <a:noFill/>
         </p:spPr>
         <p:txBody>
-          <a:bodyPr wrap="square" lIns="0" rIns="0" tIns="0" bIns="0" anchor="t">
+          <a:bodyPr wrap="square" lIns="0" tIns="0" rIns="0" bIns="0" anchor="t">
             <a:spAutoFit/>
           </a:bodyPr>
           <a:lstStyle/>
           <a:p>
             <a:pPr algn="l"/>
             <a:r>
-              <a:rPr sz="2000" b="0">
+              <a:rPr sz="2000" b="0" dirty="0">
                 <a:solidFill>
                   <a:srgbClr val="9457FF"/>
                 </a:solidFill>
@@ -5887,7 +5962,7 @@
           <a:noFill/>
         </p:spPr>
         <p:txBody>
-          <a:bodyPr wrap="square" lIns="0" rIns="0" tIns="0" bIns="0">
+          <a:bodyPr wrap="square" lIns="0" tIns="0" rIns="0" bIns="0">
             <a:spAutoFit/>
           </a:bodyPr>
           <a:lstStyle/>
@@ -6014,7 +6089,7 @@
 </file>
 
 <file path=ppt/slides/slide4.xml><?xml version="1.0" encoding="utf-8"?>
-<p:sld xmlns:a="http://schemas.openxmlformats.org/drawingml/2006/main" xmlns:p="http://schemas.openxmlformats.org/presentationml/2006/main" xmlns:r="http://schemas.openxmlformats.org/officeDocument/2006/relationships">
+<p:sld xmlns:a="http://schemas.openxmlformats.org/drawingml/2006/main" xmlns:r="http://schemas.openxmlformats.org/officeDocument/2006/relationships" xmlns:p="http://schemas.openxmlformats.org/presentationml/2006/main">
   <p:cSld>
     <p:spTree>
       <p:nvGrpSpPr>
@@ -6022,7 +6097,14 @@
         <p:cNvGrpSpPr/>
         <p:nvPr/>
       </p:nvGrpSpPr>
-      <p:grpSpPr/>
+      <p:grpSpPr>
+        <a:xfrm>
+          <a:off x="0" y="0"/>
+          <a:ext cx="0" cy="0"/>
+          <a:chOff x="0" y="0"/>
+          <a:chExt cx="0" cy="0"/>
+        </a:xfrm>
+      </p:grpSpPr>
       <p:sp>
         <p:nvSpPr>
           <p:cNvPr id="2" name="Rectangle 1"/>
@@ -6064,6 +6146,7 @@
           <a:lstStyle/>
           <a:p>
             <a:pPr algn="ctr"/>
+            <a:endParaRPr/>
           </a:p>
         </p:txBody>
       </p:sp>
@@ -6109,6 +6192,7 @@
           <a:lstStyle/>
           <a:p>
             <a:pPr algn="ctr"/>
+            <a:endParaRPr/>
           </a:p>
         </p:txBody>
       </p:sp>
@@ -6154,6 +6238,7 @@
           <a:lstStyle/>
           <a:p>
             <a:pPr algn="ctr"/>
+            <a:endParaRPr/>
           </a:p>
         </p:txBody>
       </p:sp>
@@ -6197,6 +6282,7 @@
           <a:lstStyle/>
           <a:p>
             <a:pPr algn="ctr"/>
+            <a:endParaRPr/>
           </a:p>
         </p:txBody>
       </p:sp>
@@ -6217,7 +6303,7 @@
           <a:noFill/>
         </p:spPr>
         <p:txBody>
-          <a:bodyPr wrap="square" lIns="0" rIns="0" tIns="0" bIns="0" anchor="t">
+          <a:bodyPr wrap="square" lIns="0" tIns="0" rIns="0" bIns="0" anchor="t">
             <a:spAutoFit/>
           </a:bodyPr>
           <a:lstStyle/>
@@ -6252,7 +6338,7 @@
           <a:noFill/>
         </p:spPr>
         <p:txBody>
-          <a:bodyPr wrap="square" lIns="0" rIns="0" tIns="0" bIns="0" anchor="t">
+          <a:bodyPr wrap="square" lIns="0" tIns="0" rIns="0" bIns="0" anchor="t">
             <a:spAutoFit/>
           </a:bodyPr>
           <a:lstStyle/>
@@ -6309,7 +6395,7 @@
           </a:fontRef>
         </p:style>
         <p:txBody>
-          <a:bodyPr rtlCol="0" anchor="ctr" lIns="0" rIns="0" tIns="0" bIns="0"/>
+          <a:bodyPr lIns="0" tIns="0" rIns="0" bIns="0" rtlCol="0" anchor="ctr"/>
           <a:lstStyle/>
           <a:p>
             <a:pPr algn="ctr"/>
@@ -6342,7 +6428,7 @@
           <a:noFill/>
         </p:spPr>
         <p:txBody>
-          <a:bodyPr wrap="square" lIns="0" rIns="0" tIns="0" bIns="0" anchor="t">
+          <a:bodyPr wrap="square" lIns="0" tIns="0" rIns="0" bIns="0" anchor="t">
             <a:spAutoFit/>
           </a:bodyPr>
           <a:lstStyle/>
@@ -6399,7 +6485,7 @@
           </a:fontRef>
         </p:style>
         <p:txBody>
-          <a:bodyPr rtlCol="0" anchor="ctr" lIns="0" rIns="0" tIns="0" bIns="0"/>
+          <a:bodyPr lIns="0" tIns="0" rIns="0" bIns="0" rtlCol="0" anchor="ctr"/>
           <a:lstStyle/>
           <a:p>
             <a:pPr algn="ctr"/>
@@ -6432,7 +6518,7 @@
           <a:noFill/>
         </p:spPr>
         <p:txBody>
-          <a:bodyPr wrap="square" lIns="0" rIns="0" tIns="0" bIns="0" anchor="t">
+          <a:bodyPr wrap="square" lIns="0" tIns="0" rIns="0" bIns="0" anchor="t">
             <a:spAutoFit/>
           </a:bodyPr>
           <a:lstStyle/>
@@ -6489,7 +6575,7 @@
           </a:fontRef>
         </p:style>
         <p:txBody>
-          <a:bodyPr rtlCol="0" anchor="ctr" lIns="0" rIns="0" tIns="0" bIns="0"/>
+          <a:bodyPr lIns="0" tIns="0" rIns="0" bIns="0" rtlCol="0" anchor="ctr"/>
           <a:lstStyle/>
           <a:p>
             <a:pPr algn="ctr"/>
@@ -6522,7 +6608,7 @@
           <a:noFill/>
         </p:spPr>
         <p:txBody>
-          <a:bodyPr wrap="square" lIns="0" rIns="0" tIns="0" bIns="0" anchor="t">
+          <a:bodyPr wrap="square" lIns="0" tIns="0" rIns="0" bIns="0" anchor="t">
             <a:spAutoFit/>
           </a:bodyPr>
           <a:lstStyle/>
@@ -6579,7 +6665,7 @@
           </a:fontRef>
         </p:style>
         <p:txBody>
-          <a:bodyPr rtlCol="0" anchor="ctr" lIns="0" rIns="0" tIns="0" bIns="0"/>
+          <a:bodyPr lIns="0" tIns="0" rIns="0" bIns="0" rtlCol="0" anchor="ctr"/>
           <a:lstStyle/>
           <a:p>
             <a:pPr algn="ctr"/>
@@ -6612,7 +6698,7 @@
           <a:noFill/>
         </p:spPr>
         <p:txBody>
-          <a:bodyPr wrap="square" lIns="0" rIns="0" tIns="0" bIns="0" anchor="t">
+          <a:bodyPr wrap="square" lIns="0" tIns="0" rIns="0" bIns="0" anchor="t">
             <a:spAutoFit/>
           </a:bodyPr>
           <a:lstStyle/>
@@ -6669,7 +6755,7 @@
           </a:fontRef>
         </p:style>
         <p:txBody>
-          <a:bodyPr rtlCol="0" anchor="ctr" lIns="0" rIns="0" tIns="0" bIns="0"/>
+          <a:bodyPr lIns="0" tIns="0" rIns="0" bIns="0" rtlCol="0" anchor="ctr"/>
           <a:lstStyle/>
           <a:p>
             <a:pPr algn="ctr"/>
@@ -6702,7 +6788,7 @@
           <a:noFill/>
         </p:spPr>
         <p:txBody>
-          <a:bodyPr wrap="square" lIns="0" rIns="0" tIns="0" bIns="0" anchor="t">
+          <a:bodyPr wrap="square" lIns="0" tIns="0" rIns="0" bIns="0" anchor="t">
             <a:spAutoFit/>
           </a:bodyPr>
           <a:lstStyle/>
@@ -6759,7 +6845,7 @@
           </a:fontRef>
         </p:style>
         <p:txBody>
-          <a:bodyPr rtlCol="0" anchor="ctr" lIns="0" rIns="0" tIns="0" bIns="0"/>
+          <a:bodyPr lIns="0" tIns="0" rIns="0" bIns="0" rtlCol="0" anchor="ctr"/>
           <a:lstStyle/>
           <a:p>
             <a:pPr algn="ctr"/>
@@ -6792,7 +6878,7 @@
           <a:noFill/>
         </p:spPr>
         <p:txBody>
-          <a:bodyPr wrap="square" lIns="0" rIns="0" tIns="0" bIns="0" anchor="t">
+          <a:bodyPr wrap="square" lIns="0" tIns="0" rIns="0" bIns="0" anchor="t">
             <a:spAutoFit/>
           </a:bodyPr>
           <a:lstStyle/>
@@ -6849,7 +6935,7 @@
           </a:fontRef>
         </p:style>
         <p:txBody>
-          <a:bodyPr rtlCol="0" anchor="ctr" lIns="0" rIns="0" tIns="0" bIns="0"/>
+          <a:bodyPr lIns="0" tIns="0" rIns="0" bIns="0" rtlCol="0" anchor="ctr"/>
           <a:lstStyle/>
           <a:p>
             <a:pPr algn="ctr"/>
@@ -6882,7 +6968,7 @@
           <a:noFill/>
         </p:spPr>
         <p:txBody>
-          <a:bodyPr wrap="square" lIns="0" rIns="0" tIns="0" bIns="0" anchor="t">
+          <a:bodyPr wrap="square" lIns="0" tIns="0" rIns="0" bIns="0" anchor="t">
             <a:spAutoFit/>
           </a:bodyPr>
           <a:lstStyle/>
@@ -6939,7 +7025,7 @@
           </a:fontRef>
         </p:style>
         <p:txBody>
-          <a:bodyPr rtlCol="0" anchor="ctr" lIns="0" rIns="0" tIns="0" bIns="0"/>
+          <a:bodyPr lIns="0" tIns="0" rIns="0" bIns="0" rtlCol="0" anchor="ctr"/>
           <a:lstStyle/>
           <a:p>
             <a:pPr algn="ctr"/>
@@ -6972,7 +7058,7 @@
           <a:noFill/>
         </p:spPr>
         <p:txBody>
-          <a:bodyPr wrap="square" lIns="0" rIns="0" tIns="0" bIns="0" anchor="t">
+          <a:bodyPr wrap="square" lIns="0" tIns="0" rIns="0" bIns="0" anchor="t">
             <a:spAutoFit/>
           </a:bodyPr>
           <a:lstStyle/>
@@ -6999,7 +7085,7 @@
 </file>
 
 <file path=ppt/slides/slide5.xml><?xml version="1.0" encoding="utf-8"?>
-<p:sld xmlns:a="http://schemas.openxmlformats.org/drawingml/2006/main" xmlns:p="http://schemas.openxmlformats.org/presentationml/2006/main" xmlns:r="http://schemas.openxmlformats.org/officeDocument/2006/relationships">
+<p:sld xmlns:a="http://schemas.openxmlformats.org/drawingml/2006/main" xmlns:r="http://schemas.openxmlformats.org/officeDocument/2006/relationships" xmlns:p="http://schemas.openxmlformats.org/presentationml/2006/main">
   <p:cSld>
     <p:spTree>
       <p:nvGrpSpPr>
@@ -7007,7 +7093,14 @@
         <p:cNvGrpSpPr/>
         <p:nvPr/>
       </p:nvGrpSpPr>
-      <p:grpSpPr/>
+      <p:grpSpPr>
+        <a:xfrm>
+          <a:off x="0" y="0"/>
+          <a:ext cx="0" cy="0"/>
+          <a:chOff x="0" y="0"/>
+          <a:chExt cx="0" cy="0"/>
+        </a:xfrm>
+      </p:grpSpPr>
       <p:sp>
         <p:nvSpPr>
           <p:cNvPr id="2" name="Rectangle 1"/>
@@ -7049,6 +7142,7 @@
           <a:lstStyle/>
           <a:p>
             <a:pPr algn="ctr"/>
+            <a:endParaRPr/>
           </a:p>
         </p:txBody>
       </p:sp>
@@ -7094,6 +7188,7 @@
           <a:lstStyle/>
           <a:p>
             <a:pPr algn="ctr"/>
+            <a:endParaRPr/>
           </a:p>
         </p:txBody>
       </p:sp>
@@ -7139,6 +7234,7 @@
           <a:lstStyle/>
           <a:p>
             <a:pPr algn="ctr"/>
+            <a:endParaRPr/>
           </a:p>
         </p:txBody>
       </p:sp>
@@ -7182,6 +7278,7 @@
           <a:lstStyle/>
           <a:p>
             <a:pPr algn="ctr"/>
+            <a:endParaRPr/>
           </a:p>
         </p:txBody>
       </p:sp>
@@ -7202,7 +7299,7 @@
           <a:noFill/>
         </p:spPr>
         <p:txBody>
-          <a:bodyPr wrap="square" lIns="0" rIns="0" tIns="0" bIns="0" anchor="t">
+          <a:bodyPr wrap="square" lIns="0" tIns="0" rIns="0" bIns="0" anchor="t">
             <a:spAutoFit/>
           </a:bodyPr>
           <a:lstStyle/>
@@ -7237,7 +7334,7 @@
           <a:noFill/>
         </p:spPr>
         <p:txBody>
-          <a:bodyPr wrap="square" lIns="0" rIns="0" tIns="0" bIns="0" anchor="t">
+          <a:bodyPr wrap="square" lIns="0" tIns="0" rIns="0" bIns="0" anchor="t">
             <a:spAutoFit/>
           </a:bodyPr>
           <a:lstStyle/>
@@ -7302,6 +7399,7 @@
           <a:lstStyle/>
           <a:p>
             <a:pPr algn="ctr"/>
+            <a:endParaRPr/>
           </a:p>
         </p:txBody>
       </p:sp>
@@ -7322,14 +7420,14 @@
           <a:noFill/>
         </p:spPr>
         <p:txBody>
-          <a:bodyPr wrap="square" lIns="0" rIns="0" tIns="0" bIns="0" anchor="t">
+          <a:bodyPr wrap="square" lIns="0" tIns="0" rIns="0" bIns="0" anchor="t">
             <a:spAutoFit/>
           </a:bodyPr>
           <a:lstStyle/>
           <a:p>
             <a:pPr algn="l"/>
             <a:r>
-              <a:rPr sz="2000" b="1">
+              <a:rPr sz="2000" b="1" dirty="0">
                 <a:solidFill>
                   <a:srgbClr val="6366F1"/>
                 </a:solidFill>
@@ -7357,7 +7455,7 @@
           <a:noFill/>
         </p:spPr>
         <p:txBody>
-          <a:bodyPr wrap="square" lIns="0" rIns="0" tIns="0" bIns="0" anchor="t">
+          <a:bodyPr wrap="square" lIns="0" tIns="0" rIns="0" bIns="0" anchor="t">
             <a:spAutoFit/>
           </a:bodyPr>
           <a:lstStyle/>
@@ -7423,6 +7521,7 @@
           <a:lstStyle/>
           <a:p>
             <a:pPr algn="ctr"/>
+            <a:endParaRPr/>
           </a:p>
         </p:txBody>
       </p:sp>
@@ -7435,7 +7534,7 @@
         <p:spPr>
           <a:xfrm>
             <a:off x="4709160" y="2514600"/>
-            <a:ext cx="3108960" cy="457200"/>
+            <a:ext cx="3108960" cy="307777"/>
           </a:xfrm>
           <a:prstGeom prst="rect">
             <a:avLst/>
@@ -7443,14 +7542,14 @@
           <a:noFill/>
         </p:spPr>
         <p:txBody>
-          <a:bodyPr wrap="square" lIns="0" rIns="0" tIns="0" bIns="0" anchor="t">
+          <a:bodyPr wrap="square" lIns="0" tIns="0" rIns="0" bIns="0" anchor="t">
             <a:spAutoFit/>
           </a:bodyPr>
           <a:lstStyle/>
           <a:p>
-            <a:pPr algn="l"/>
-            <a:r>
-              <a:rPr sz="2000" b="1">
+            <a:pPr algn="ctr"/>
+            <a:r>
+              <a:rPr sz="2000" b="1" dirty="0">
                 <a:solidFill>
                   <a:srgbClr val="9457FF"/>
                 </a:solidFill>
@@ -7470,7 +7569,7 @@
         <p:spPr>
           <a:xfrm>
             <a:off x="4709160" y="3154680"/>
-            <a:ext cx="3108960" cy="2103120"/>
+            <a:ext cx="3108960" cy="738664"/>
           </a:xfrm>
           <a:prstGeom prst="rect">
             <a:avLst/>
@@ -7478,14 +7577,14 @@
           <a:noFill/>
         </p:spPr>
         <p:txBody>
-          <a:bodyPr wrap="square" lIns="0" rIns="0" tIns="0" bIns="0" anchor="t">
+          <a:bodyPr wrap="square" lIns="0" tIns="0" rIns="0" bIns="0" anchor="t">
             <a:spAutoFit/>
           </a:bodyPr>
           <a:lstStyle/>
           <a:p>
-            <a:pPr algn="l"/>
-            <a:r>
-              <a:rPr sz="1600" b="0">
+            <a:pPr algn="ctr"/>
+            <a:r>
+              <a:rPr sz="1600" b="0" dirty="0">
                 <a:solidFill>
                   <a:srgbClr val="EDEDF2"/>
                 </a:solidFill>
@@ -7545,6 +7644,7 @@
           <a:lstStyle/>
           <a:p>
             <a:pPr algn="ctr"/>
+            <a:endParaRPr/>
           </a:p>
         </p:txBody>
       </p:sp>
@@ -7557,7 +7657,7 @@
         <p:spPr>
           <a:xfrm>
             <a:off x="8549640" y="2514600"/>
-            <a:ext cx="3108960" cy="457200"/>
+            <a:ext cx="3108960" cy="307777"/>
           </a:xfrm>
           <a:prstGeom prst="rect">
             <a:avLst/>
@@ -7565,14 +7665,14 @@
           <a:noFill/>
         </p:spPr>
         <p:txBody>
-          <a:bodyPr wrap="square" lIns="0" rIns="0" tIns="0" bIns="0" anchor="t">
+          <a:bodyPr wrap="square" lIns="0" tIns="0" rIns="0" bIns="0" anchor="t">
             <a:spAutoFit/>
           </a:bodyPr>
           <a:lstStyle/>
           <a:p>
-            <a:pPr algn="l"/>
-            <a:r>
-              <a:rPr sz="2000" b="1">
+            <a:pPr algn="ctr"/>
+            <a:r>
+              <a:rPr sz="2000" b="1" dirty="0">
                 <a:solidFill>
                   <a:srgbClr val="10B981"/>
                 </a:solidFill>
@@ -7592,7 +7692,7 @@
         <p:spPr>
           <a:xfrm>
             <a:off x="8549640" y="3154680"/>
-            <a:ext cx="3108960" cy="2103120"/>
+            <a:ext cx="3108960" cy="738664"/>
           </a:xfrm>
           <a:prstGeom prst="rect">
             <a:avLst/>
@@ -7600,14 +7700,14 @@
           <a:noFill/>
         </p:spPr>
         <p:txBody>
-          <a:bodyPr wrap="square" lIns="0" rIns="0" tIns="0" bIns="0" anchor="t">
+          <a:bodyPr wrap="square" lIns="0" tIns="0" rIns="0" bIns="0" anchor="t">
             <a:spAutoFit/>
           </a:bodyPr>
           <a:lstStyle/>
           <a:p>
-            <a:pPr algn="l"/>
-            <a:r>
-              <a:rPr sz="1600" b="0">
+            <a:pPr algn="ctr"/>
+            <a:r>
+              <a:rPr sz="1600" b="0" dirty="0">
                 <a:solidFill>
                   <a:srgbClr val="EDEDF2"/>
                 </a:solidFill>
@@ -7637,7 +7737,7 @@
           <a:noFill/>
         </p:spPr>
         <p:txBody>
-          <a:bodyPr wrap="square" lIns="0" rIns="0" tIns="0" bIns="0" anchor="t">
+          <a:bodyPr wrap="square" lIns="0" tIns="0" rIns="0" bIns="0" anchor="t">
             <a:spAutoFit/>
           </a:bodyPr>
           <a:lstStyle/>
@@ -7664,7 +7764,7 @@
 </file>
 
 <file path=ppt/slides/slide6.xml><?xml version="1.0" encoding="utf-8"?>
-<p:sld xmlns:a="http://schemas.openxmlformats.org/drawingml/2006/main" xmlns:p="http://schemas.openxmlformats.org/presentationml/2006/main" xmlns:r="http://schemas.openxmlformats.org/officeDocument/2006/relationships">
+<p:sld xmlns:a="http://schemas.openxmlformats.org/drawingml/2006/main" xmlns:r="http://schemas.openxmlformats.org/officeDocument/2006/relationships" xmlns:p="http://schemas.openxmlformats.org/presentationml/2006/main">
   <p:cSld>
     <p:spTree>
       <p:nvGrpSpPr>
@@ -7672,7 +7772,14 @@
         <p:cNvGrpSpPr/>
         <p:nvPr/>
       </p:nvGrpSpPr>
-      <p:grpSpPr/>
+      <p:grpSpPr>
+        <a:xfrm>
+          <a:off x="0" y="0"/>
+          <a:ext cx="0" cy="0"/>
+          <a:chOff x="0" y="0"/>
+          <a:chExt cx="0" cy="0"/>
+        </a:xfrm>
+      </p:grpSpPr>
       <p:sp>
         <p:nvSpPr>
           <p:cNvPr id="2" name="Rectangle 1"/>
@@ -7714,6 +7821,7 @@
           <a:lstStyle/>
           <a:p>
             <a:pPr algn="ctr"/>
+            <a:endParaRPr/>
           </a:p>
         </p:txBody>
       </p:sp>
@@ -7759,6 +7867,7 @@
           <a:lstStyle/>
           <a:p>
             <a:pPr algn="ctr"/>
+            <a:endParaRPr/>
           </a:p>
         </p:txBody>
       </p:sp>
@@ -7804,6 +7913,7 @@
           <a:lstStyle/>
           <a:p>
             <a:pPr algn="ctr"/>
+            <a:endParaRPr/>
           </a:p>
         </p:txBody>
       </p:sp>
@@ -7847,6 +7957,7 @@
           <a:lstStyle/>
           <a:p>
             <a:pPr algn="ctr"/>
+            <a:endParaRPr/>
           </a:p>
         </p:txBody>
       </p:sp>
@@ -7867,7 +7978,7 @@
           <a:noFill/>
         </p:spPr>
         <p:txBody>
-          <a:bodyPr wrap="square" lIns="0" rIns="0" tIns="0" bIns="0" anchor="t">
+          <a:bodyPr wrap="square" lIns="0" tIns="0" rIns="0" bIns="0" anchor="t">
             <a:spAutoFit/>
           </a:bodyPr>
           <a:lstStyle/>
@@ -7902,7 +8013,7 @@
           <a:noFill/>
         </p:spPr>
         <p:txBody>
-          <a:bodyPr wrap="square" lIns="0" rIns="0" tIns="0" bIns="0" anchor="t">
+          <a:bodyPr wrap="square" lIns="0" tIns="0" rIns="0" bIns="0" anchor="t">
             <a:spAutoFit/>
           </a:bodyPr>
           <a:lstStyle/>
@@ -7937,7 +8048,7 @@
           <a:noFill/>
         </p:spPr>
         <p:txBody>
-          <a:bodyPr wrap="square" lIns="0" rIns="0" tIns="0" bIns="0">
+          <a:bodyPr wrap="square" lIns="0" tIns="0" rIns="0" bIns="0">
             <a:spAutoFit/>
           </a:bodyPr>
           <a:lstStyle/>
@@ -8102,6 +8213,7 @@
           <a:lstStyle/>
           <a:p>
             <a:pPr algn="ctr"/>
+            <a:endParaRPr/>
           </a:p>
         </p:txBody>
       </p:sp>
@@ -8122,7 +8234,7 @@
           <a:noFill/>
         </p:spPr>
         <p:txBody>
-          <a:bodyPr wrap="square" lIns="0" rIns="0" tIns="0" bIns="0" anchor="t">
+          <a:bodyPr wrap="square" lIns="0" tIns="0" rIns="0" bIns="0" anchor="t">
             <a:spAutoFit/>
           </a:bodyPr>
           <a:lstStyle/>
@@ -8157,7 +8269,7 @@
           <a:noFill/>
         </p:spPr>
         <p:txBody>
-          <a:bodyPr wrap="square" lIns="0" rIns="0" tIns="0" bIns="0" anchor="t">
+          <a:bodyPr wrap="square" lIns="0" tIns="0" rIns="0" bIns="0" anchor="t">
             <a:spAutoFit/>
           </a:bodyPr>
           <a:lstStyle/>
@@ -8192,7 +8304,7 @@
           <a:noFill/>
         </p:spPr>
         <p:txBody>
-          <a:bodyPr wrap="square" lIns="0" rIns="0" tIns="0" bIns="0" anchor="t">
+          <a:bodyPr wrap="square" lIns="0" tIns="0" rIns="0" bIns="0" anchor="t">
             <a:spAutoFit/>
           </a:bodyPr>
           <a:lstStyle/>
@@ -8227,7 +8339,7 @@
           <a:noFill/>
         </p:spPr>
         <p:txBody>
-          <a:bodyPr wrap="square" lIns="0" rIns="0" tIns="0" bIns="0" anchor="t">
+          <a:bodyPr wrap="square" lIns="0" tIns="0" rIns="0" bIns="0" anchor="t">
             <a:spAutoFit/>
           </a:bodyPr>
           <a:lstStyle/>
@@ -8262,7 +8374,7 @@
           <a:noFill/>
         </p:spPr>
         <p:txBody>
-          <a:bodyPr wrap="square" lIns="0" rIns="0" tIns="0" bIns="0" anchor="t">
+          <a:bodyPr wrap="square" lIns="0" tIns="0" rIns="0" bIns="0" anchor="t">
             <a:spAutoFit/>
           </a:bodyPr>
           <a:lstStyle/>
@@ -8297,7 +8409,7 @@
           <a:noFill/>
         </p:spPr>
         <p:txBody>
-          <a:bodyPr wrap="square" lIns="0" rIns="0" tIns="0" bIns="0" anchor="t">
+          <a:bodyPr wrap="square" lIns="0" tIns="0" rIns="0" bIns="0" anchor="t">
             <a:spAutoFit/>
           </a:bodyPr>
           <a:lstStyle/>
@@ -8324,7 +8436,7 @@
 </file>
 
 <file path=ppt/slides/slide7.xml><?xml version="1.0" encoding="utf-8"?>
-<p:sld xmlns:a="http://schemas.openxmlformats.org/drawingml/2006/main" xmlns:p="http://schemas.openxmlformats.org/presentationml/2006/main" xmlns:r="http://schemas.openxmlformats.org/officeDocument/2006/relationships">
+<p:sld xmlns:a="http://schemas.openxmlformats.org/drawingml/2006/main" xmlns:r="http://schemas.openxmlformats.org/officeDocument/2006/relationships" xmlns:p="http://schemas.openxmlformats.org/presentationml/2006/main">
   <p:cSld>
     <p:spTree>
       <p:nvGrpSpPr>
@@ -8332,7 +8444,14 @@
         <p:cNvGrpSpPr/>
         <p:nvPr/>
       </p:nvGrpSpPr>
-      <p:grpSpPr/>
+      <p:grpSpPr>
+        <a:xfrm>
+          <a:off x="0" y="0"/>
+          <a:ext cx="0" cy="0"/>
+          <a:chOff x="0" y="0"/>
+          <a:chExt cx="0" cy="0"/>
+        </a:xfrm>
+      </p:grpSpPr>
       <p:sp>
         <p:nvSpPr>
           <p:cNvPr id="2" name="Rectangle 1"/>
@@ -8374,6 +8493,7 @@
           <a:lstStyle/>
           <a:p>
             <a:pPr algn="ctr"/>
+            <a:endParaRPr/>
           </a:p>
         </p:txBody>
       </p:sp>
@@ -8419,6 +8539,7 @@
           <a:lstStyle/>
           <a:p>
             <a:pPr algn="ctr"/>
+            <a:endParaRPr/>
           </a:p>
         </p:txBody>
       </p:sp>
@@ -8464,6 +8585,7 @@
           <a:lstStyle/>
           <a:p>
             <a:pPr algn="ctr"/>
+            <a:endParaRPr/>
           </a:p>
         </p:txBody>
       </p:sp>
@@ -8507,6 +8629,7 @@
           <a:lstStyle/>
           <a:p>
             <a:pPr algn="ctr"/>
+            <a:endParaRPr/>
           </a:p>
         </p:txBody>
       </p:sp>
@@ -8527,7 +8650,7 @@
           <a:noFill/>
         </p:spPr>
         <p:txBody>
-          <a:bodyPr wrap="square" lIns="0" rIns="0" tIns="0" bIns="0" anchor="t">
+          <a:bodyPr wrap="square" lIns="0" tIns="0" rIns="0" bIns="0" anchor="t">
             <a:spAutoFit/>
           </a:bodyPr>
           <a:lstStyle/>
@@ -8562,7 +8685,7 @@
           <a:noFill/>
         </p:spPr>
         <p:txBody>
-          <a:bodyPr wrap="square" lIns="0" rIns="0" tIns="0" bIns="0" anchor="t">
+          <a:bodyPr wrap="square" lIns="0" tIns="0" rIns="0" bIns="0" anchor="t">
             <a:spAutoFit/>
           </a:bodyPr>
           <a:lstStyle/>
@@ -8619,7 +8742,7 @@
           </a:fontRef>
         </p:style>
         <p:txBody>
-          <a:bodyPr rtlCol="0" anchor="ctr" lIns="0" rIns="0" tIns="0" bIns="0"/>
+          <a:bodyPr lIns="0" tIns="0" rIns="0" bIns="0" rtlCol="0" anchor="ctr"/>
           <a:lstStyle/>
           <a:p>
             <a:pPr algn="ctr"/>
@@ -8652,7 +8775,7 @@
           <a:noFill/>
         </p:spPr>
         <p:txBody>
-          <a:bodyPr wrap="square" lIns="0" rIns="0" tIns="0" bIns="0" anchor="t">
+          <a:bodyPr wrap="square" lIns="0" tIns="0" rIns="0" bIns="0" anchor="t">
             <a:spAutoFit/>
           </a:bodyPr>
           <a:lstStyle/>
@@ -8709,7 +8832,7 @@
           </a:fontRef>
         </p:style>
         <p:txBody>
-          <a:bodyPr rtlCol="0" anchor="ctr" lIns="0" rIns="0" tIns="0" bIns="0"/>
+          <a:bodyPr lIns="0" tIns="0" rIns="0" bIns="0" rtlCol="0" anchor="ctr"/>
           <a:lstStyle/>
           <a:p>
             <a:pPr algn="ctr"/>
@@ -8742,7 +8865,7 @@
           <a:noFill/>
         </p:spPr>
         <p:txBody>
-          <a:bodyPr wrap="square" lIns="0" rIns="0" tIns="0" bIns="0" anchor="t">
+          <a:bodyPr wrap="square" lIns="0" tIns="0" rIns="0" bIns="0" anchor="t">
             <a:spAutoFit/>
           </a:bodyPr>
           <a:lstStyle/>
@@ -8799,7 +8922,7 @@
           </a:fontRef>
         </p:style>
         <p:txBody>
-          <a:bodyPr rtlCol="0" anchor="ctr" lIns="0" rIns="0" tIns="0" bIns="0"/>
+          <a:bodyPr lIns="0" tIns="0" rIns="0" bIns="0" rtlCol="0" anchor="ctr"/>
           <a:lstStyle/>
           <a:p>
             <a:pPr algn="ctr"/>
@@ -8832,7 +8955,7 @@
           <a:noFill/>
         </p:spPr>
         <p:txBody>
-          <a:bodyPr wrap="square" lIns="0" rIns="0" tIns="0" bIns="0" anchor="t">
+          <a:bodyPr wrap="square" lIns="0" tIns="0" rIns="0" bIns="0" anchor="t">
             <a:spAutoFit/>
           </a:bodyPr>
           <a:lstStyle/>
@@ -8889,7 +9012,7 @@
           </a:fontRef>
         </p:style>
         <p:txBody>
-          <a:bodyPr rtlCol="0" anchor="ctr" lIns="0" rIns="0" tIns="0" bIns="0"/>
+          <a:bodyPr lIns="0" tIns="0" rIns="0" bIns="0" rtlCol="0" anchor="ctr"/>
           <a:lstStyle/>
           <a:p>
             <a:pPr algn="ctr"/>
@@ -8922,7 +9045,7 @@
           <a:noFill/>
         </p:spPr>
         <p:txBody>
-          <a:bodyPr wrap="square" lIns="0" rIns="0" tIns="0" bIns="0" anchor="t">
+          <a:bodyPr wrap="square" lIns="0" tIns="0" rIns="0" bIns="0" anchor="t">
             <a:spAutoFit/>
           </a:bodyPr>
           <a:lstStyle/>
@@ -8949,7 +9072,7 @@
 </file>
 
 <file path=ppt/slides/slide8.xml><?xml version="1.0" encoding="utf-8"?>
-<p:sld xmlns:a="http://schemas.openxmlformats.org/drawingml/2006/main" xmlns:p="http://schemas.openxmlformats.org/presentationml/2006/main" xmlns:r="http://schemas.openxmlformats.org/officeDocument/2006/relationships">
+<p:sld xmlns:a="http://schemas.openxmlformats.org/drawingml/2006/main" xmlns:r="http://schemas.openxmlformats.org/officeDocument/2006/relationships" xmlns:p="http://schemas.openxmlformats.org/presentationml/2006/main">
   <p:cSld>
     <p:spTree>
       <p:nvGrpSpPr>
@@ -8957,7 +9080,14 @@
         <p:cNvGrpSpPr/>
         <p:nvPr/>
       </p:nvGrpSpPr>
-      <p:grpSpPr/>
+      <p:grpSpPr>
+        <a:xfrm>
+          <a:off x="0" y="0"/>
+          <a:ext cx="0" cy="0"/>
+          <a:chOff x="0" y="0"/>
+          <a:chExt cx="0" cy="0"/>
+        </a:xfrm>
+      </p:grpSpPr>
       <p:sp>
         <p:nvSpPr>
           <p:cNvPr id="2" name="Rectangle 1"/>
@@ -8999,6 +9129,7 @@
           <a:lstStyle/>
           <a:p>
             <a:pPr algn="ctr"/>
+            <a:endParaRPr/>
           </a:p>
         </p:txBody>
       </p:sp>
@@ -9044,6 +9175,7 @@
           <a:lstStyle/>
           <a:p>
             <a:pPr algn="ctr"/>
+            <a:endParaRPr/>
           </a:p>
         </p:txBody>
       </p:sp>
@@ -9089,6 +9221,7 @@
           <a:lstStyle/>
           <a:p>
             <a:pPr algn="ctr"/>
+            <a:endParaRPr/>
           </a:p>
         </p:txBody>
       </p:sp>
@@ -9132,6 +9265,7 @@
           <a:lstStyle/>
           <a:p>
             <a:pPr algn="ctr"/>
+            <a:endParaRPr/>
           </a:p>
         </p:txBody>
       </p:sp>
@@ -9152,7 +9286,7 @@
           <a:noFill/>
         </p:spPr>
         <p:txBody>
-          <a:bodyPr wrap="square" lIns="0" rIns="0" tIns="0" bIns="0" anchor="t">
+          <a:bodyPr wrap="square" lIns="0" tIns="0" rIns="0" bIns="0" anchor="t">
             <a:spAutoFit/>
           </a:bodyPr>
           <a:lstStyle/>
@@ -9187,7 +9321,7 @@
           <a:noFill/>
         </p:spPr>
         <p:txBody>
-          <a:bodyPr wrap="square" lIns="0" rIns="0" tIns="0" bIns="0" anchor="t">
+          <a:bodyPr wrap="square" lIns="0" tIns="0" rIns="0" bIns="0" anchor="t">
             <a:spAutoFit/>
           </a:bodyPr>
           <a:lstStyle/>
@@ -9244,7 +9378,7 @@
           </a:fontRef>
         </p:style>
         <p:txBody>
-          <a:bodyPr rtlCol="0" anchor="ctr" lIns="0" rIns="0" tIns="0" bIns="0"/>
+          <a:bodyPr lIns="0" tIns="0" rIns="0" bIns="0" rtlCol="0" anchor="ctr"/>
           <a:lstStyle/>
           <a:p>
             <a:pPr algn="ctr"/>
@@ -9277,7 +9411,7 @@
           <a:noFill/>
         </p:spPr>
         <p:txBody>
-          <a:bodyPr wrap="square" lIns="0" rIns="0" tIns="0" bIns="0" anchor="t">
+          <a:bodyPr wrap="square" lIns="0" tIns="0" rIns="0" bIns="0" anchor="t">
             <a:spAutoFit/>
           </a:bodyPr>
           <a:lstStyle/>
@@ -9334,7 +9468,7 @@
           </a:fontRef>
         </p:style>
         <p:txBody>
-          <a:bodyPr rtlCol="0" anchor="ctr" lIns="0" rIns="0" tIns="0" bIns="0"/>
+          <a:bodyPr lIns="0" tIns="0" rIns="0" bIns="0" rtlCol="0" anchor="ctr"/>
           <a:lstStyle/>
           <a:p>
             <a:pPr algn="ctr"/>
@@ -9367,7 +9501,7 @@
           <a:noFill/>
         </p:spPr>
         <p:txBody>
-          <a:bodyPr wrap="square" lIns="0" rIns="0" tIns="0" bIns="0" anchor="t">
+          <a:bodyPr wrap="square" lIns="0" tIns="0" rIns="0" bIns="0" anchor="t">
             <a:spAutoFit/>
           </a:bodyPr>
           <a:lstStyle/>
@@ -9424,7 +9558,7 @@
           </a:fontRef>
         </p:style>
         <p:txBody>
-          <a:bodyPr rtlCol="0" anchor="ctr" lIns="0" rIns="0" tIns="0" bIns="0"/>
+          <a:bodyPr lIns="0" tIns="0" rIns="0" bIns="0" rtlCol="0" anchor="ctr"/>
           <a:lstStyle/>
           <a:p>
             <a:pPr algn="ctr"/>
@@ -9457,7 +9591,7 @@
           <a:noFill/>
         </p:spPr>
         <p:txBody>
-          <a:bodyPr wrap="square" lIns="0" rIns="0" tIns="0" bIns="0" anchor="t">
+          <a:bodyPr wrap="square" lIns="0" tIns="0" rIns="0" bIns="0" anchor="t">
             <a:spAutoFit/>
           </a:bodyPr>
           <a:lstStyle/>
@@ -9514,7 +9648,7 @@
           </a:fontRef>
         </p:style>
         <p:txBody>
-          <a:bodyPr rtlCol="0" anchor="ctr" lIns="0" rIns="0" tIns="0" bIns="0"/>
+          <a:bodyPr lIns="0" tIns="0" rIns="0" bIns="0" rtlCol="0" anchor="ctr"/>
           <a:lstStyle/>
           <a:p>
             <a:pPr algn="ctr"/>
@@ -9547,7 +9681,7 @@
           <a:noFill/>
         </p:spPr>
         <p:txBody>
-          <a:bodyPr wrap="square" lIns="0" rIns="0" tIns="0" bIns="0" anchor="t">
+          <a:bodyPr wrap="square" lIns="0" tIns="0" rIns="0" bIns="0" anchor="t">
             <a:spAutoFit/>
           </a:bodyPr>
           <a:lstStyle/>
@@ -9604,7 +9738,7 @@
           </a:fontRef>
         </p:style>
         <p:txBody>
-          <a:bodyPr rtlCol="0" anchor="ctr" lIns="0" rIns="0" tIns="0" bIns="0"/>
+          <a:bodyPr lIns="0" tIns="0" rIns="0" bIns="0" rtlCol="0" anchor="ctr"/>
           <a:lstStyle/>
           <a:p>
             <a:pPr algn="ctr"/>
@@ -9637,7 +9771,7 @@
           <a:noFill/>
         </p:spPr>
         <p:txBody>
-          <a:bodyPr wrap="square" lIns="0" rIns="0" tIns="0" bIns="0" anchor="t">
+          <a:bodyPr wrap="square" lIns="0" tIns="0" rIns="0" bIns="0" anchor="t">
             <a:spAutoFit/>
           </a:bodyPr>
           <a:lstStyle/>
@@ -9694,7 +9828,7 @@
           </a:fontRef>
         </p:style>
         <p:txBody>
-          <a:bodyPr rtlCol="0" anchor="ctr" lIns="0" rIns="0" tIns="0" bIns="0"/>
+          <a:bodyPr lIns="0" tIns="0" rIns="0" bIns="0" rtlCol="0" anchor="ctr"/>
           <a:lstStyle/>
           <a:p>
             <a:pPr algn="ctr"/>
@@ -9727,7 +9861,7 @@
           <a:noFill/>
         </p:spPr>
         <p:txBody>
-          <a:bodyPr wrap="square" lIns="0" rIns="0" tIns="0" bIns="0" anchor="t">
+          <a:bodyPr wrap="square" lIns="0" tIns="0" rIns="0" bIns="0" anchor="t">
             <a:spAutoFit/>
           </a:bodyPr>
           <a:lstStyle/>
@@ -9754,7 +9888,7 @@
 </file>
 
 <file path=ppt/slides/slide9.xml><?xml version="1.0" encoding="utf-8"?>
-<p:sld xmlns:a="http://schemas.openxmlformats.org/drawingml/2006/main" xmlns:p="http://schemas.openxmlformats.org/presentationml/2006/main" xmlns:r="http://schemas.openxmlformats.org/officeDocument/2006/relationships">
+<p:sld xmlns:a="http://schemas.openxmlformats.org/drawingml/2006/main" xmlns:r="http://schemas.openxmlformats.org/officeDocument/2006/relationships" xmlns:p="http://schemas.openxmlformats.org/presentationml/2006/main">
   <p:cSld>
     <p:spTree>
       <p:nvGrpSpPr>
@@ -9762,7 +9896,14 @@
         <p:cNvGrpSpPr/>
         <p:nvPr/>
       </p:nvGrpSpPr>
-      <p:grpSpPr/>
+      <p:grpSpPr>
+        <a:xfrm>
+          <a:off x="0" y="0"/>
+          <a:ext cx="0" cy="0"/>
+          <a:chOff x="0" y="0"/>
+          <a:chExt cx="0" cy="0"/>
+        </a:xfrm>
+      </p:grpSpPr>
       <p:sp>
         <p:nvSpPr>
           <p:cNvPr id="2" name="Rectangle 1"/>
@@ -9804,6 +9945,7 @@
           <a:lstStyle/>
           <a:p>
             <a:pPr algn="ctr"/>
+            <a:endParaRPr/>
           </a:p>
         </p:txBody>
       </p:sp>
@@ -9849,6 +9991,7 @@
           <a:lstStyle/>
           <a:p>
             <a:pPr algn="ctr"/>
+            <a:endParaRPr/>
           </a:p>
         </p:txBody>
       </p:sp>
@@ -9894,6 +10037,7 @@
           <a:lstStyle/>
           <a:p>
             <a:pPr algn="ctr"/>
+            <a:endParaRPr/>
           </a:p>
         </p:txBody>
       </p:sp>
@@ -9937,6 +10081,7 @@
           <a:lstStyle/>
           <a:p>
             <a:pPr algn="ctr"/>
+            <a:endParaRPr/>
           </a:p>
         </p:txBody>
       </p:sp>
@@ -9957,7 +10102,7 @@
           <a:noFill/>
         </p:spPr>
         <p:txBody>
-          <a:bodyPr wrap="square" lIns="0" rIns="0" tIns="0" bIns="0" anchor="t">
+          <a:bodyPr wrap="square" lIns="0" tIns="0" rIns="0" bIns="0" anchor="t">
             <a:spAutoFit/>
           </a:bodyPr>
           <a:lstStyle/>
@@ -9992,7 +10137,7 @@
           <a:noFill/>
         </p:spPr>
         <p:txBody>
-          <a:bodyPr wrap="square" lIns="0" rIns="0" tIns="0" bIns="0" anchor="t">
+          <a:bodyPr wrap="square" lIns="0" tIns="0" rIns="0" bIns="0" anchor="t">
             <a:spAutoFit/>
           </a:bodyPr>
           <a:lstStyle/>
@@ -10027,7 +10172,7 @@
           <a:noFill/>
         </p:spPr>
         <p:txBody>
-          <a:bodyPr wrap="square" lIns="0" rIns="0" tIns="0" bIns="0">
+          <a:bodyPr wrap="square" lIns="0" tIns="0" rIns="0" bIns="0">
             <a:spAutoFit/>
           </a:bodyPr>
           <a:lstStyle/>

</xml_diff>